<commit_message>
Fix slide deck layout overflow
</commit_message>
<xml_diff>
--- a/email/文字題實戰_加減乘判斷.pptx
+++ b/email/文字題實戰_加減乘判斷.pptx
@@ -10355,7 +10355,7 @@
         <p:spPr>
           <a:xfrm>
             <a:off x="1325880" y="1901952"/>
-            <a:ext cx="1005840" cy="320040"/>
+            <a:ext cx="1005840" cy="292608"/>
           </a:xfrm>
           <a:prstGeom prst="rect">
             <a:avLst/>
@@ -10462,7 +10462,7 @@
         <p:spPr>
           <a:xfrm>
             <a:off x="2743200" y="2295144"/>
-            <a:ext cx="7452360" cy="420624"/>
+            <a:ext cx="7452360" cy="310896"/>
           </a:xfrm>
           <a:prstGeom prst="rect">
             <a:avLst/>
@@ -10569,7 +10569,7 @@
         <p:spPr>
           <a:xfrm>
             <a:off x="2743200" y="2697480"/>
-            <a:ext cx="7452360" cy="420624"/>
+            <a:ext cx="7452360" cy="292608"/>
           </a:xfrm>
           <a:prstGeom prst="rect">
             <a:avLst/>
@@ -10676,7 +10676,7 @@
         <p:spPr>
           <a:xfrm>
             <a:off x="2743200" y="3090672"/>
-            <a:ext cx="7452360" cy="420624"/>
+            <a:ext cx="7452360" cy="292608"/>
           </a:xfrm>
           <a:prstGeom prst="rect">
             <a:avLst/>
@@ -10783,7 +10783,7 @@
         <p:spPr>
           <a:xfrm>
             <a:off x="1325880" y="4233672"/>
-            <a:ext cx="1005840" cy="320040"/>
+            <a:ext cx="1005840" cy="292608"/>
           </a:xfrm>
           <a:prstGeom prst="rect">
             <a:avLst/>
@@ -10890,7 +10890,7 @@
         <p:spPr>
           <a:xfrm>
             <a:off x="2743200" y="4626864"/>
-            <a:ext cx="7452360" cy="420624"/>
+            <a:ext cx="7452360" cy="310896"/>
           </a:xfrm>
           <a:prstGeom prst="rect">
             <a:avLst/>
@@ -10997,7 +10997,7 @@
         <p:spPr>
           <a:xfrm>
             <a:off x="2743200" y="5029200"/>
-            <a:ext cx="7452360" cy="420624"/>
+            <a:ext cx="7452360" cy="292608"/>
           </a:xfrm>
           <a:prstGeom prst="rect">
             <a:avLst/>
@@ -11104,7 +11104,7 @@
         <p:spPr>
           <a:xfrm>
             <a:off x="2743200" y="5422392"/>
-            <a:ext cx="7452360" cy="420624"/>
+            <a:ext cx="7452360" cy="292608"/>
           </a:xfrm>
           <a:prstGeom prst="rect">
             <a:avLst/>
@@ -15723,7 +15723,7 @@
         <p:spPr>
           <a:xfrm>
             <a:off x="1325880" y="1901952"/>
-            <a:ext cx="1005840" cy="320040"/>
+            <a:ext cx="1005840" cy="292608"/>
           </a:xfrm>
           <a:prstGeom prst="rect">
             <a:avLst/>
@@ -15830,7 +15830,7 @@
         <p:spPr>
           <a:xfrm>
             <a:off x="2743200" y="2295144"/>
-            <a:ext cx="7452360" cy="420624"/>
+            <a:ext cx="7452360" cy="310896"/>
           </a:xfrm>
           <a:prstGeom prst="rect">
             <a:avLst/>
@@ -15937,7 +15937,7 @@
         <p:spPr>
           <a:xfrm>
             <a:off x="2743200" y="2697480"/>
-            <a:ext cx="7452360" cy="420624"/>
+            <a:ext cx="7452360" cy="292608"/>
           </a:xfrm>
           <a:prstGeom prst="rect">
             <a:avLst/>
@@ -16044,7 +16044,7 @@
         <p:spPr>
           <a:xfrm>
             <a:off x="2743200" y="3090672"/>
-            <a:ext cx="7452360" cy="420624"/>
+            <a:ext cx="7452360" cy="292608"/>
           </a:xfrm>
           <a:prstGeom prst="rect">
             <a:avLst/>
@@ -16151,7 +16151,7 @@
         <p:spPr>
           <a:xfrm>
             <a:off x="1325880" y="4233672"/>
-            <a:ext cx="1005840" cy="320040"/>
+            <a:ext cx="1005840" cy="292608"/>
           </a:xfrm>
           <a:prstGeom prst="rect">
             <a:avLst/>
@@ -16258,7 +16258,7 @@
         <p:spPr>
           <a:xfrm>
             <a:off x="2743200" y="4626864"/>
-            <a:ext cx="7452360" cy="420624"/>
+            <a:ext cx="7452360" cy="310896"/>
           </a:xfrm>
           <a:prstGeom prst="rect">
             <a:avLst/>
@@ -16365,7 +16365,7 @@
         <p:spPr>
           <a:xfrm>
             <a:off x="2743200" y="5029200"/>
-            <a:ext cx="7452360" cy="420624"/>
+            <a:ext cx="7452360" cy="292608"/>
           </a:xfrm>
           <a:prstGeom prst="rect">
             <a:avLst/>
@@ -16472,7 +16472,7 @@
         <p:spPr>
           <a:xfrm>
             <a:off x="2743200" y="5422392"/>
-            <a:ext cx="7452360" cy="420624"/>
+            <a:ext cx="7452360" cy="292608"/>
           </a:xfrm>
           <a:prstGeom prst="rect">
             <a:avLst/>
@@ -22273,7 +22273,7 @@
         <p:spPr>
           <a:xfrm>
             <a:off x="1325880" y="1901952"/>
-            <a:ext cx="1005840" cy="320040"/>
+            <a:ext cx="1005840" cy="292608"/>
           </a:xfrm>
           <a:prstGeom prst="rect">
             <a:avLst/>
@@ -22380,7 +22380,7 @@
         <p:spPr>
           <a:xfrm>
             <a:off x="2743200" y="2295144"/>
-            <a:ext cx="7452360" cy="420624"/>
+            <a:ext cx="7452360" cy="310896"/>
           </a:xfrm>
           <a:prstGeom prst="rect">
             <a:avLst/>
@@ -22487,7 +22487,7 @@
         <p:spPr>
           <a:xfrm>
             <a:off x="2743200" y="2697480"/>
-            <a:ext cx="7452360" cy="420624"/>
+            <a:ext cx="7452360" cy="292608"/>
           </a:xfrm>
           <a:prstGeom prst="rect">
             <a:avLst/>
@@ -22594,7 +22594,7 @@
         <p:spPr>
           <a:xfrm>
             <a:off x="2743200" y="3090672"/>
-            <a:ext cx="7452360" cy="420624"/>
+            <a:ext cx="7452360" cy="292608"/>
           </a:xfrm>
           <a:prstGeom prst="rect">
             <a:avLst/>
@@ -22701,7 +22701,7 @@
         <p:spPr>
           <a:xfrm>
             <a:off x="1325880" y="4233672"/>
-            <a:ext cx="1005840" cy="320040"/>
+            <a:ext cx="1005840" cy="292608"/>
           </a:xfrm>
           <a:prstGeom prst="rect">
             <a:avLst/>
@@ -22808,7 +22808,7 @@
         <p:spPr>
           <a:xfrm>
             <a:off x="2743200" y="4626864"/>
-            <a:ext cx="7452360" cy="420624"/>
+            <a:ext cx="7452360" cy="310896"/>
           </a:xfrm>
           <a:prstGeom prst="rect">
             <a:avLst/>
@@ -22915,7 +22915,7 @@
         <p:spPr>
           <a:xfrm>
             <a:off x="2743200" y="5029200"/>
-            <a:ext cx="7452360" cy="420624"/>
+            <a:ext cx="7452360" cy="292608"/>
           </a:xfrm>
           <a:prstGeom prst="rect">
             <a:avLst/>
@@ -23022,7 +23022,7 @@
         <p:spPr>
           <a:xfrm>
             <a:off x="2743200" y="5422392"/>
-            <a:ext cx="7452360" cy="420624"/>
+            <a:ext cx="7452360" cy="292608"/>
           </a:xfrm>
           <a:prstGeom prst="rect">
             <a:avLst/>
@@ -33133,8 +33133,8 @@
         </p:nvSpPr>
         <p:spPr>
           <a:xfrm>
-            <a:off x="713232" y="1691640"/>
-            <a:ext cx="10332720" cy="1874520"/>
+            <a:off x="713232" y="1572768"/>
+            <a:ext cx="10332720" cy="1261872"/>
           </a:xfrm>
           <a:prstGeom prst="roundRect">
             <a:avLst/>
@@ -33158,8 +33158,8 @@
         </p:nvSpPr>
         <p:spPr>
           <a:xfrm>
-            <a:off x="896112" y="1947672"/>
-            <a:ext cx="384048" cy="384048"/>
+            <a:off x="896112" y="1700784"/>
+            <a:ext cx="314919" cy="314919"/>
           </a:xfrm>
           <a:prstGeom prst="rect">
             <a:avLst/>
@@ -33177,7 +33177,7 @@
               <a:buNone/>
             </a:pPr>
             <a:r>
-              <a:rPr lang="en-US" sz="2600" b="1" dirty="0">
+              <a:rPr lang="en-US" sz="2132" b="1" dirty="0">
                 <a:solidFill>
                   <a:srgbClr val="166534"/>
                 </a:solidFill>
@@ -33187,7 +33187,7 @@
               </a:rPr>
               <a:t>✓</a:t>
             </a:r>
-            <a:endParaRPr lang="en-US" sz="2600" dirty="0"/>
+            <a:endParaRPr lang="en-US" sz="2132" dirty="0"/>
           </a:p>
         </p:txBody>
       </p:sp>
@@ -33199,8 +33199,8 @@
         </p:nvSpPr>
         <p:spPr>
           <a:xfrm>
-            <a:off x="1325880" y="1901952"/>
-            <a:ext cx="1005840" cy="320040"/>
+            <a:off x="1325880" y="1709928"/>
+            <a:ext cx="1005840" cy="292608"/>
           </a:xfrm>
           <a:prstGeom prst="rect">
             <a:avLst/>
@@ -33218,7 +33218,7 @@
               <a:buNone/>
             </a:pPr>
             <a:r>
-              <a:rPr lang="en-US" sz="1900" b="1" dirty="0">
+              <a:rPr lang="en-US" sz="1600" b="1" dirty="0">
                 <a:solidFill>
                   <a:srgbClr val="7C3AED"/>
                 </a:solidFill>
@@ -33228,7 +33228,7 @@
               </a:rPr>
               <a:t>題目 A</a:t>
             </a:r>
-            <a:endParaRPr lang="en-US" sz="1900" dirty="0"/>
+            <a:endParaRPr lang="en-US" sz="1600" dirty="0"/>
           </a:p>
         </p:txBody>
       </p:sp>
@@ -33240,7 +33240,7 @@
         </p:nvSpPr>
         <p:spPr>
           <a:xfrm>
-            <a:off x="1325880" y="2313432"/>
+            <a:off x="1325880" y="2020824"/>
             <a:ext cx="1234440" cy="310896"/>
           </a:xfrm>
           <a:prstGeom prst="roundRect">
@@ -33265,7 +33265,7 @@
         </p:nvSpPr>
         <p:spPr>
           <a:xfrm>
-            <a:off x="1353312" y="2331720"/>
+            <a:off x="1353312" y="2039112"/>
             <a:ext cx="1179576" cy="274320"/>
           </a:xfrm>
           <a:prstGeom prst="rect">
@@ -33284,7 +33284,7 @@
               <a:buNone/>
             </a:pPr>
             <a:r>
-              <a:rPr lang="en-US" sz="1300" b="1" dirty="0">
+              <a:rPr lang="en-US" sz="1100" b="1" dirty="0">
                 <a:solidFill>
                   <a:srgbClr val="7C3AED"/>
                 </a:solidFill>
@@ -33294,20 +33294,127 @@
               </a:rPr>
               <a:t>重點字</a:t>
             </a:r>
+            <a:endParaRPr lang="en-US" sz="1100" dirty="0"/>
+          </a:p>
+        </p:txBody>
+      </p:sp>
+      <p:sp>
+        <p:nvSpPr>
+          <p:cNvPr id="27" name="Text 25"/>
+          <p:cNvSpPr/>
+          <p:nvPr/>
+        </p:nvSpPr>
+        <p:spPr>
+          <a:xfrm>
+            <a:off x="2743200" y="2002536"/>
+            <a:ext cx="7452360" cy="310896"/>
+          </a:xfrm>
+          <a:prstGeom prst="rect">
+            <a:avLst/>
+          </a:prstGeom>
+          <a:noFill/>
+          <a:ln/>
+        </p:spPr>
+        <p:txBody>
+          <a:bodyPr wrap="square" lIns="635" tIns="635" rIns="635" bIns="635" rtlCol="0" anchor="ctr">
+            <a:normAutofit/>
+          </a:bodyPr>
+          <a:lstStyle/>
+          <a:p>
+            <a:pPr algn="l" indent="0" marL="0">
+              <a:buNone/>
+            </a:pPr>
+            <a:r>
+              <a:rPr lang="en-US" sz="1300" dirty="0">
+                <a:solidFill>
+                  <a:srgbClr val="163044"/>
+                </a:solidFill>
+                <a:latin typeface="Microsoft JhengHei" pitchFamily="34" charset="0"/>
+                <a:ea typeface="Microsoft JhengHei" pitchFamily="34" charset="-122"/>
+                <a:cs typeface="Microsoft JhengHei" pitchFamily="34" charset="-120"/>
+              </a:rPr>
+              <a:t>再給、現在</a:t>
+            </a:r>
             <a:endParaRPr lang="en-US" sz="1300" dirty="0"/>
           </a:p>
         </p:txBody>
       </p:sp>
       <p:sp>
         <p:nvSpPr>
-          <p:cNvPr id="27" name="Text 25"/>
-          <p:cNvSpPr/>
-          <p:nvPr/>
-        </p:nvSpPr>
-        <p:spPr>
-          <a:xfrm>
-            <a:off x="2743200" y="2295144"/>
-            <a:ext cx="7452360" cy="420624"/>
+          <p:cNvPr id="28" name="Shape 26"/>
+          <p:cNvSpPr/>
+          <p:nvPr/>
+        </p:nvSpPr>
+        <p:spPr>
+          <a:xfrm>
+            <a:off x="1325880" y="2304288"/>
+            <a:ext cx="1234440" cy="310896"/>
+          </a:xfrm>
+          <a:prstGeom prst="roundRect">
+            <a:avLst/>
+          </a:prstGeom>
+          <a:solidFill>
+            <a:srgbClr val="F3E8FF"/>
+          </a:solidFill>
+          <a:ln w="21590">
+            <a:solidFill>
+              <a:srgbClr val="7C3AED"/>
+            </a:solidFill>
+            <a:prstDash val="solid"/>
+          </a:ln>
+        </p:spPr>
+      </p:sp>
+      <p:sp>
+        <p:nvSpPr>
+          <p:cNvPr id="29" name="Text 27"/>
+          <p:cNvSpPr/>
+          <p:nvPr/>
+        </p:nvSpPr>
+        <p:spPr>
+          <a:xfrm>
+            <a:off x="1353312" y="2322576"/>
+            <a:ext cx="1179576" cy="274320"/>
+          </a:xfrm>
+          <a:prstGeom prst="rect">
+            <a:avLst/>
+          </a:prstGeom>
+          <a:noFill/>
+          <a:ln/>
+        </p:spPr>
+        <p:txBody>
+          <a:bodyPr wrap="square" lIns="635" tIns="635" rIns="635" bIns="635" rtlCol="0" anchor="ctr">
+            <a:normAutofit/>
+          </a:bodyPr>
+          <a:lstStyle/>
+          <a:p>
+            <a:pPr algn="ctr" indent="0" marL="0">
+              <a:buNone/>
+            </a:pPr>
+            <a:r>
+              <a:rPr lang="en-US" sz="1100" b="1" dirty="0">
+                <a:solidFill>
+                  <a:srgbClr val="7C3AED"/>
+                </a:solidFill>
+                <a:latin typeface="Microsoft JhengHei" pitchFamily="34" charset="0"/>
+                <a:ea typeface="Microsoft JhengHei" pitchFamily="34" charset="-122"/>
+                <a:cs typeface="Microsoft JhengHei" pitchFamily="34" charset="-120"/>
+              </a:rPr>
+              <a:t>判斷</a:t>
+            </a:r>
+            <a:endParaRPr lang="en-US" sz="1100" dirty="0"/>
+          </a:p>
+        </p:txBody>
+      </p:sp>
+      <p:sp>
+        <p:nvSpPr>
+          <p:cNvPr id="30" name="Text 28"/>
+          <p:cNvSpPr/>
+          <p:nvPr/>
+        </p:nvSpPr>
+        <p:spPr>
+          <a:xfrm>
+            <a:off x="2743200" y="2286000"/>
+            <a:ext cx="7452360" cy="292608"/>
           </a:xfrm>
           <a:prstGeom prst="rect">
             <a:avLst/>
@@ -33325,7 +33432,7 @@
               <a:buNone/>
             </a:pPr>
             <a:r>
-              <a:rPr lang="en-US" sz="1600" dirty="0">
+              <a:rPr lang="en-US" sz="1250" dirty="0">
                 <a:solidFill>
                   <a:srgbClr val="163044"/>
                 </a:solidFill>
@@ -33333,7 +33440,221 @@
                 <a:ea typeface="Microsoft JhengHei" pitchFamily="34" charset="-122"/>
                 <a:cs typeface="Microsoft JhengHei" pitchFamily="34" charset="-120"/>
               </a:rPr>
-              <a:t>再給、現在</a:t>
+              <a:t>數量增加，用加法。</a:t>
+            </a:r>
+            <a:endParaRPr lang="en-US" sz="1250" dirty="0"/>
+          </a:p>
+        </p:txBody>
+      </p:sp>
+      <p:sp>
+        <p:nvSpPr>
+          <p:cNvPr id="31" name="Shape 29"/>
+          <p:cNvSpPr/>
+          <p:nvPr/>
+        </p:nvSpPr>
+        <p:spPr>
+          <a:xfrm>
+            <a:off x="1325880" y="2578608"/>
+            <a:ext cx="1234440" cy="310896"/>
+          </a:xfrm>
+          <a:prstGeom prst="roundRect">
+            <a:avLst/>
+          </a:prstGeom>
+          <a:solidFill>
+            <a:srgbClr val="F3E8FF"/>
+          </a:solidFill>
+          <a:ln w="21590">
+            <a:solidFill>
+              <a:srgbClr val="7C3AED"/>
+            </a:solidFill>
+            <a:prstDash val="solid"/>
+          </a:ln>
+        </p:spPr>
+      </p:sp>
+      <p:sp>
+        <p:nvSpPr>
+          <p:cNvPr id="32" name="Text 30"/>
+          <p:cNvSpPr/>
+          <p:nvPr/>
+        </p:nvSpPr>
+        <p:spPr>
+          <a:xfrm>
+            <a:off x="1353312" y="2596896"/>
+            <a:ext cx="1179576" cy="274320"/>
+          </a:xfrm>
+          <a:prstGeom prst="rect">
+            <a:avLst/>
+          </a:prstGeom>
+          <a:noFill/>
+          <a:ln/>
+        </p:spPr>
+        <p:txBody>
+          <a:bodyPr wrap="square" lIns="635" tIns="635" rIns="635" bIns="635" rtlCol="0" anchor="ctr">
+            <a:normAutofit/>
+          </a:bodyPr>
+          <a:lstStyle/>
+          <a:p>
+            <a:pPr algn="ctr" indent="0" marL="0">
+              <a:buNone/>
+            </a:pPr>
+            <a:r>
+              <a:rPr lang="en-US" sz="1100" b="1" dirty="0">
+                <a:solidFill>
+                  <a:srgbClr val="7C3AED"/>
+                </a:solidFill>
+                <a:latin typeface="Microsoft JhengHei" pitchFamily="34" charset="0"/>
+                <a:ea typeface="Microsoft JhengHei" pitchFamily="34" charset="-122"/>
+                <a:cs typeface="Microsoft JhengHei" pitchFamily="34" charset="-120"/>
+              </a:rPr>
+              <a:t>算式</a:t>
+            </a:r>
+            <a:endParaRPr lang="en-US" sz="1100" dirty="0"/>
+          </a:p>
+        </p:txBody>
+      </p:sp>
+      <p:sp>
+        <p:nvSpPr>
+          <p:cNvPr id="33" name="Text 31"/>
+          <p:cNvSpPr/>
+          <p:nvPr/>
+        </p:nvSpPr>
+        <p:spPr>
+          <a:xfrm>
+            <a:off x="2743200" y="2560320"/>
+            <a:ext cx="7452360" cy="292608"/>
+          </a:xfrm>
+          <a:prstGeom prst="rect">
+            <a:avLst/>
+          </a:prstGeom>
+          <a:noFill/>
+          <a:ln/>
+        </p:spPr>
+        <p:txBody>
+          <a:bodyPr wrap="square" lIns="635" tIns="635" rIns="635" bIns="635" rtlCol="0" anchor="ctr">
+            <a:normAutofit/>
+          </a:bodyPr>
+          <a:lstStyle/>
+          <a:p>
+            <a:pPr algn="l" indent="0" marL="0">
+              <a:buNone/>
+            </a:pPr>
+            <a:r>
+              <a:rPr lang="en-US" sz="1550" b="1" dirty="0">
+                <a:solidFill>
+                  <a:srgbClr val="7C3AED"/>
+                </a:solidFill>
+                <a:latin typeface="Microsoft JhengHei" pitchFamily="34" charset="0"/>
+                <a:ea typeface="Microsoft JhengHei" pitchFamily="34" charset="-122"/>
+                <a:cs typeface="Microsoft JhengHei" pitchFamily="34" charset="-120"/>
+              </a:rPr>
+              <a:t>12 ＋ 6 ＝ 18</a:t>
+            </a:r>
+            <a:endParaRPr lang="en-US" sz="1550" dirty="0"/>
+          </a:p>
+        </p:txBody>
+      </p:sp>
+      <p:sp>
+        <p:nvSpPr>
+          <p:cNvPr id="34" name="Shape 32"/>
+          <p:cNvSpPr/>
+          <p:nvPr/>
+        </p:nvSpPr>
+        <p:spPr>
+          <a:xfrm>
+            <a:off x="713232" y="3108960"/>
+            <a:ext cx="10332720" cy="1261872"/>
+          </a:xfrm>
+          <a:prstGeom prst="roundRect">
+            <a:avLst/>
+          </a:prstGeom>
+          <a:solidFill>
+            <a:srgbClr val="FFFFFF"/>
+          </a:solidFill>
+          <a:ln w="25400">
+            <a:solidFill>
+              <a:srgbClr val="DDD6FE"/>
+            </a:solidFill>
+            <a:prstDash val="solid"/>
+          </a:ln>
+        </p:spPr>
+      </p:sp>
+      <p:sp>
+        <p:nvSpPr>
+          <p:cNvPr id="35" name="Text 33"/>
+          <p:cNvSpPr/>
+          <p:nvPr/>
+        </p:nvSpPr>
+        <p:spPr>
+          <a:xfrm>
+            <a:off x="896112" y="3236976"/>
+            <a:ext cx="314919" cy="314919"/>
+          </a:xfrm>
+          <a:prstGeom prst="rect">
+            <a:avLst/>
+          </a:prstGeom>
+          <a:noFill/>
+          <a:ln/>
+        </p:spPr>
+        <p:txBody>
+          <a:bodyPr wrap="square" lIns="635" tIns="635" rIns="635" bIns="635" rtlCol="0" anchor="ctr">
+            <a:normAutofit/>
+          </a:bodyPr>
+          <a:lstStyle/>
+          <a:p>
+            <a:pPr algn="ctr" indent="0" marL="0">
+              <a:buNone/>
+            </a:pPr>
+            <a:r>
+              <a:rPr lang="en-US" sz="2132" b="1" dirty="0">
+                <a:solidFill>
+                  <a:srgbClr val="166534"/>
+                </a:solidFill>
+                <a:latin typeface="Microsoft JhengHei" pitchFamily="34" charset="0"/>
+                <a:ea typeface="Microsoft JhengHei" pitchFamily="34" charset="-122"/>
+                <a:cs typeface="Microsoft JhengHei" pitchFamily="34" charset="-120"/>
+              </a:rPr>
+              <a:t>✓</a:t>
+            </a:r>
+            <a:endParaRPr lang="en-US" sz="2132" dirty="0"/>
+          </a:p>
+        </p:txBody>
+      </p:sp>
+      <p:sp>
+        <p:nvSpPr>
+          <p:cNvPr id="36" name="Text 34"/>
+          <p:cNvSpPr/>
+          <p:nvPr/>
+        </p:nvSpPr>
+        <p:spPr>
+          <a:xfrm>
+            <a:off x="1325880" y="3246120"/>
+            <a:ext cx="1005840" cy="292608"/>
+          </a:xfrm>
+          <a:prstGeom prst="rect">
+            <a:avLst/>
+          </a:prstGeom>
+          <a:noFill/>
+          <a:ln/>
+        </p:spPr>
+        <p:txBody>
+          <a:bodyPr wrap="square" lIns="635" tIns="635" rIns="635" bIns="635" rtlCol="0" anchor="ctr">
+            <a:normAutofit/>
+          </a:bodyPr>
+          <a:lstStyle/>
+          <a:p>
+            <a:pPr algn="l" indent="0" marL="0">
+              <a:buNone/>
+            </a:pPr>
+            <a:r>
+              <a:rPr lang="en-US" sz="1600" b="1" dirty="0">
+                <a:solidFill>
+                  <a:srgbClr val="7C3AED"/>
+                </a:solidFill>
+                <a:latin typeface="Microsoft JhengHei" pitchFamily="34" charset="0"/>
+                <a:ea typeface="Microsoft JhengHei" pitchFamily="34" charset="-122"/>
+                <a:cs typeface="Microsoft JhengHei" pitchFamily="34" charset="-120"/>
+              </a:rPr>
+              <a:t>題目 B</a:t>
             </a:r>
             <a:endParaRPr lang="en-US" sz="1600" dirty="0"/>
           </a:p>
@@ -33341,13 +33662,13 @@
       </p:sp>
       <p:sp>
         <p:nvSpPr>
-          <p:cNvPr id="28" name="Shape 26"/>
-          <p:cNvSpPr/>
-          <p:nvPr/>
-        </p:nvSpPr>
-        <p:spPr>
-          <a:xfrm>
-            <a:off x="1325880" y="2715768"/>
+          <p:cNvPr id="37" name="Shape 35"/>
+          <p:cNvSpPr/>
+          <p:nvPr/>
+        </p:nvSpPr>
+        <p:spPr>
+          <a:xfrm>
+            <a:off x="1325880" y="3557016"/>
             <a:ext cx="1234440" cy="310896"/>
           </a:xfrm>
           <a:prstGeom prst="roundRect">
@@ -33366,13 +33687,13 @@
       </p:sp>
       <p:sp>
         <p:nvSpPr>
-          <p:cNvPr id="29" name="Text 27"/>
-          <p:cNvSpPr/>
-          <p:nvPr/>
-        </p:nvSpPr>
-        <p:spPr>
-          <a:xfrm>
-            <a:off x="1353312" y="2734056"/>
+          <p:cNvPr id="38" name="Text 36"/>
+          <p:cNvSpPr/>
+          <p:nvPr/>
+        </p:nvSpPr>
+        <p:spPr>
+          <a:xfrm>
+            <a:off x="1353312" y="3575304"/>
             <a:ext cx="1179576" cy="274320"/>
           </a:xfrm>
           <a:prstGeom prst="rect">
@@ -33391,7 +33712,7 @@
               <a:buNone/>
             </a:pPr>
             <a:r>
-              <a:rPr lang="en-US" sz="1300" b="1" dirty="0">
+              <a:rPr lang="en-US" sz="1100" b="1" dirty="0">
                 <a:solidFill>
                   <a:srgbClr val="7C3AED"/>
                 </a:solidFill>
@@ -33399,22 +33720,557 @@
                 <a:ea typeface="Microsoft JhengHei" pitchFamily="34" charset="-122"/>
                 <a:cs typeface="Microsoft JhengHei" pitchFamily="34" charset="-120"/>
               </a:rPr>
+              <a:t>重點字</a:t>
+            </a:r>
+            <a:endParaRPr lang="en-US" sz="1100" dirty="0"/>
+          </a:p>
+        </p:txBody>
+      </p:sp>
+      <p:sp>
+        <p:nvSpPr>
+          <p:cNvPr id="39" name="Text 37"/>
+          <p:cNvSpPr/>
+          <p:nvPr/>
+        </p:nvSpPr>
+        <p:spPr>
+          <a:xfrm>
+            <a:off x="2743200" y="3538728"/>
+            <a:ext cx="7452360" cy="310896"/>
+          </a:xfrm>
+          <a:prstGeom prst="rect">
+            <a:avLst/>
+          </a:prstGeom>
+          <a:noFill/>
+          <a:ln/>
+        </p:spPr>
+        <p:txBody>
+          <a:bodyPr wrap="square" lIns="635" tIns="635" rIns="635" bIns="635" rtlCol="0" anchor="ctr">
+            <a:normAutofit/>
+          </a:bodyPr>
+          <a:lstStyle/>
+          <a:p>
+            <a:pPr algn="l" indent="0" marL="0">
+              <a:buNone/>
+            </a:pPr>
+            <a:r>
+              <a:rPr lang="en-US" sz="1300" dirty="0">
+                <a:solidFill>
+                  <a:srgbClr val="163044"/>
+                </a:solidFill>
+                <a:latin typeface="Microsoft JhengHei" pitchFamily="34" charset="0"/>
+                <a:ea typeface="Microsoft JhengHei" pitchFamily="34" charset="-122"/>
+                <a:cs typeface="Microsoft JhengHei" pitchFamily="34" charset="-120"/>
+              </a:rPr>
+              <a:t>每包、有 5 包</a:t>
+            </a:r>
+            <a:endParaRPr lang="en-US" sz="1300" dirty="0"/>
+          </a:p>
+        </p:txBody>
+      </p:sp>
+      <p:sp>
+        <p:nvSpPr>
+          <p:cNvPr id="40" name="Shape 38"/>
+          <p:cNvSpPr/>
+          <p:nvPr/>
+        </p:nvSpPr>
+        <p:spPr>
+          <a:xfrm>
+            <a:off x="1325880" y="3840480"/>
+            <a:ext cx="1234440" cy="310896"/>
+          </a:xfrm>
+          <a:prstGeom prst="roundRect">
+            <a:avLst/>
+          </a:prstGeom>
+          <a:solidFill>
+            <a:srgbClr val="F3E8FF"/>
+          </a:solidFill>
+          <a:ln w="21590">
+            <a:solidFill>
+              <a:srgbClr val="7C3AED"/>
+            </a:solidFill>
+            <a:prstDash val="solid"/>
+          </a:ln>
+        </p:spPr>
+      </p:sp>
+      <p:sp>
+        <p:nvSpPr>
+          <p:cNvPr id="41" name="Text 39"/>
+          <p:cNvSpPr/>
+          <p:nvPr/>
+        </p:nvSpPr>
+        <p:spPr>
+          <a:xfrm>
+            <a:off x="1353312" y="3858768"/>
+            <a:ext cx="1179576" cy="274320"/>
+          </a:xfrm>
+          <a:prstGeom prst="rect">
+            <a:avLst/>
+          </a:prstGeom>
+          <a:noFill/>
+          <a:ln/>
+        </p:spPr>
+        <p:txBody>
+          <a:bodyPr wrap="square" lIns="635" tIns="635" rIns="635" bIns="635" rtlCol="0" anchor="ctr">
+            <a:normAutofit/>
+          </a:bodyPr>
+          <a:lstStyle/>
+          <a:p>
+            <a:pPr algn="ctr" indent="0" marL="0">
+              <a:buNone/>
+            </a:pPr>
+            <a:r>
+              <a:rPr lang="en-US" sz="1100" b="1" dirty="0">
+                <a:solidFill>
+                  <a:srgbClr val="7C3AED"/>
+                </a:solidFill>
+                <a:latin typeface="Microsoft JhengHei" pitchFamily="34" charset="0"/>
+                <a:ea typeface="Microsoft JhengHei" pitchFamily="34" charset="-122"/>
+                <a:cs typeface="Microsoft JhengHei" pitchFamily="34" charset="-120"/>
+              </a:rPr>
               <a:t>判斷</a:t>
             </a:r>
+            <a:endParaRPr lang="en-US" sz="1100" dirty="0"/>
+          </a:p>
+        </p:txBody>
+      </p:sp>
+      <p:sp>
+        <p:nvSpPr>
+          <p:cNvPr id="42" name="Text 40"/>
+          <p:cNvSpPr/>
+          <p:nvPr/>
+        </p:nvSpPr>
+        <p:spPr>
+          <a:xfrm>
+            <a:off x="2743200" y="3822192"/>
+            <a:ext cx="7452360" cy="292608"/>
+          </a:xfrm>
+          <a:prstGeom prst="rect">
+            <a:avLst/>
+          </a:prstGeom>
+          <a:noFill/>
+          <a:ln/>
+        </p:spPr>
+        <p:txBody>
+          <a:bodyPr wrap="square" lIns="635" tIns="635" rIns="635" bIns="635" rtlCol="0" anchor="ctr">
+            <a:normAutofit/>
+          </a:bodyPr>
+          <a:lstStyle/>
+          <a:p>
+            <a:pPr algn="l" indent="0" marL="0">
+              <a:buNone/>
+            </a:pPr>
+            <a:r>
+              <a:rPr lang="en-US" sz="1250" dirty="0">
+                <a:solidFill>
+                  <a:srgbClr val="163044"/>
+                </a:solidFill>
+                <a:latin typeface="Microsoft JhengHei" pitchFamily="34" charset="0"/>
+                <a:ea typeface="Microsoft JhengHei" pitchFamily="34" charset="-122"/>
+                <a:cs typeface="Microsoft JhengHei" pitchFamily="34" charset="-120"/>
+              </a:rPr>
+              <a:t>相同組數，用乘法。</a:t>
+            </a:r>
+            <a:endParaRPr lang="en-US" sz="1250" dirty="0"/>
+          </a:p>
+        </p:txBody>
+      </p:sp>
+      <p:sp>
+        <p:nvSpPr>
+          <p:cNvPr id="43" name="Shape 41"/>
+          <p:cNvSpPr/>
+          <p:nvPr/>
+        </p:nvSpPr>
+        <p:spPr>
+          <a:xfrm>
+            <a:off x="1325880" y="4114800"/>
+            <a:ext cx="1234440" cy="310896"/>
+          </a:xfrm>
+          <a:prstGeom prst="roundRect">
+            <a:avLst/>
+          </a:prstGeom>
+          <a:solidFill>
+            <a:srgbClr val="F3E8FF"/>
+          </a:solidFill>
+          <a:ln w="21590">
+            <a:solidFill>
+              <a:srgbClr val="7C3AED"/>
+            </a:solidFill>
+            <a:prstDash val="solid"/>
+          </a:ln>
+        </p:spPr>
+      </p:sp>
+      <p:sp>
+        <p:nvSpPr>
+          <p:cNvPr id="44" name="Text 42"/>
+          <p:cNvSpPr/>
+          <p:nvPr/>
+        </p:nvSpPr>
+        <p:spPr>
+          <a:xfrm>
+            <a:off x="1353312" y="4133088"/>
+            <a:ext cx="1179576" cy="274320"/>
+          </a:xfrm>
+          <a:prstGeom prst="rect">
+            <a:avLst/>
+          </a:prstGeom>
+          <a:noFill/>
+          <a:ln/>
+        </p:spPr>
+        <p:txBody>
+          <a:bodyPr wrap="square" lIns="635" tIns="635" rIns="635" bIns="635" rtlCol="0" anchor="ctr">
+            <a:normAutofit/>
+          </a:bodyPr>
+          <a:lstStyle/>
+          <a:p>
+            <a:pPr algn="ctr" indent="0" marL="0">
+              <a:buNone/>
+            </a:pPr>
+            <a:r>
+              <a:rPr lang="en-US" sz="1100" b="1" dirty="0">
+                <a:solidFill>
+                  <a:srgbClr val="7C3AED"/>
+                </a:solidFill>
+                <a:latin typeface="Microsoft JhengHei" pitchFamily="34" charset="0"/>
+                <a:ea typeface="Microsoft JhengHei" pitchFamily="34" charset="-122"/>
+                <a:cs typeface="Microsoft JhengHei" pitchFamily="34" charset="-120"/>
+              </a:rPr>
+              <a:t>算式</a:t>
+            </a:r>
+            <a:endParaRPr lang="en-US" sz="1100" dirty="0"/>
+          </a:p>
+        </p:txBody>
+      </p:sp>
+      <p:sp>
+        <p:nvSpPr>
+          <p:cNvPr id="45" name="Text 43"/>
+          <p:cNvSpPr/>
+          <p:nvPr/>
+        </p:nvSpPr>
+        <p:spPr>
+          <a:xfrm>
+            <a:off x="2743200" y="4096512"/>
+            <a:ext cx="7452360" cy="292608"/>
+          </a:xfrm>
+          <a:prstGeom prst="rect">
+            <a:avLst/>
+          </a:prstGeom>
+          <a:noFill/>
+          <a:ln/>
+        </p:spPr>
+        <p:txBody>
+          <a:bodyPr wrap="square" lIns="635" tIns="635" rIns="635" bIns="635" rtlCol="0" anchor="ctr">
+            <a:normAutofit/>
+          </a:bodyPr>
+          <a:lstStyle/>
+          <a:p>
+            <a:pPr algn="l" indent="0" marL="0">
+              <a:buNone/>
+            </a:pPr>
+            <a:r>
+              <a:rPr lang="en-US" sz="1550" b="1" dirty="0">
+                <a:solidFill>
+                  <a:srgbClr val="7C3AED"/>
+                </a:solidFill>
+                <a:latin typeface="Microsoft JhengHei" pitchFamily="34" charset="0"/>
+                <a:ea typeface="Microsoft JhengHei" pitchFamily="34" charset="-122"/>
+                <a:cs typeface="Microsoft JhengHei" pitchFamily="34" charset="-120"/>
+              </a:rPr>
+              <a:t>6 × 5 ＝ 30</a:t>
+            </a:r>
+            <a:endParaRPr lang="en-US" sz="1550" dirty="0"/>
+          </a:p>
+        </p:txBody>
+      </p:sp>
+      <p:sp>
+        <p:nvSpPr>
+          <p:cNvPr id="46" name="Shape 44"/>
+          <p:cNvSpPr/>
+          <p:nvPr/>
+        </p:nvSpPr>
+        <p:spPr>
+          <a:xfrm>
+            <a:off x="713232" y="4645152"/>
+            <a:ext cx="10332720" cy="1261872"/>
+          </a:xfrm>
+          <a:prstGeom prst="roundRect">
+            <a:avLst/>
+          </a:prstGeom>
+          <a:solidFill>
+            <a:srgbClr val="FFFFFF"/>
+          </a:solidFill>
+          <a:ln w="25400">
+            <a:solidFill>
+              <a:srgbClr val="DDD6FE"/>
+            </a:solidFill>
+            <a:prstDash val="solid"/>
+          </a:ln>
+        </p:spPr>
+      </p:sp>
+      <p:sp>
+        <p:nvSpPr>
+          <p:cNvPr id="47" name="Text 45"/>
+          <p:cNvSpPr/>
+          <p:nvPr/>
+        </p:nvSpPr>
+        <p:spPr>
+          <a:xfrm>
+            <a:off x="896112" y="4773168"/>
+            <a:ext cx="314919" cy="314919"/>
+          </a:xfrm>
+          <a:prstGeom prst="rect">
+            <a:avLst/>
+          </a:prstGeom>
+          <a:noFill/>
+          <a:ln/>
+        </p:spPr>
+        <p:txBody>
+          <a:bodyPr wrap="square" lIns="635" tIns="635" rIns="635" bIns="635" rtlCol="0" anchor="ctr">
+            <a:normAutofit/>
+          </a:bodyPr>
+          <a:lstStyle/>
+          <a:p>
+            <a:pPr algn="ctr" indent="0" marL="0">
+              <a:buNone/>
+            </a:pPr>
+            <a:r>
+              <a:rPr lang="en-US" sz="2132" b="1" dirty="0">
+                <a:solidFill>
+                  <a:srgbClr val="166534"/>
+                </a:solidFill>
+                <a:latin typeface="Microsoft JhengHei" pitchFamily="34" charset="0"/>
+                <a:ea typeface="Microsoft JhengHei" pitchFamily="34" charset="-122"/>
+                <a:cs typeface="Microsoft JhengHei" pitchFamily="34" charset="-120"/>
+              </a:rPr>
+              <a:t>✓</a:t>
+            </a:r>
+            <a:endParaRPr lang="en-US" sz="2132" dirty="0"/>
+          </a:p>
+        </p:txBody>
+      </p:sp>
+      <p:sp>
+        <p:nvSpPr>
+          <p:cNvPr id="48" name="Text 46"/>
+          <p:cNvSpPr/>
+          <p:nvPr/>
+        </p:nvSpPr>
+        <p:spPr>
+          <a:xfrm>
+            <a:off x="1325880" y="4782312"/>
+            <a:ext cx="1005840" cy="292608"/>
+          </a:xfrm>
+          <a:prstGeom prst="rect">
+            <a:avLst/>
+          </a:prstGeom>
+          <a:noFill/>
+          <a:ln/>
+        </p:spPr>
+        <p:txBody>
+          <a:bodyPr wrap="square" lIns="635" tIns="635" rIns="635" bIns="635" rtlCol="0" anchor="ctr">
+            <a:normAutofit/>
+          </a:bodyPr>
+          <a:lstStyle/>
+          <a:p>
+            <a:pPr algn="l" indent="0" marL="0">
+              <a:buNone/>
+            </a:pPr>
+            <a:r>
+              <a:rPr lang="en-US" sz="1600" b="1" dirty="0">
+                <a:solidFill>
+                  <a:srgbClr val="7C3AED"/>
+                </a:solidFill>
+                <a:latin typeface="Microsoft JhengHei" pitchFamily="34" charset="0"/>
+                <a:ea typeface="Microsoft JhengHei" pitchFamily="34" charset="-122"/>
+                <a:cs typeface="Microsoft JhengHei" pitchFamily="34" charset="-120"/>
+              </a:rPr>
+              <a:t>題目 C</a:t>
+            </a:r>
+            <a:endParaRPr lang="en-US" sz="1600" dirty="0"/>
+          </a:p>
+        </p:txBody>
+      </p:sp>
+      <p:sp>
+        <p:nvSpPr>
+          <p:cNvPr id="49" name="Shape 47"/>
+          <p:cNvSpPr/>
+          <p:nvPr/>
+        </p:nvSpPr>
+        <p:spPr>
+          <a:xfrm>
+            <a:off x="1325880" y="5093208"/>
+            <a:ext cx="1234440" cy="310896"/>
+          </a:xfrm>
+          <a:prstGeom prst="roundRect">
+            <a:avLst/>
+          </a:prstGeom>
+          <a:solidFill>
+            <a:srgbClr val="F3E8FF"/>
+          </a:solidFill>
+          <a:ln w="21590">
+            <a:solidFill>
+              <a:srgbClr val="7C3AED"/>
+            </a:solidFill>
+            <a:prstDash val="solid"/>
+          </a:ln>
+        </p:spPr>
+      </p:sp>
+      <p:sp>
+        <p:nvSpPr>
+          <p:cNvPr id="50" name="Text 48"/>
+          <p:cNvSpPr/>
+          <p:nvPr/>
+        </p:nvSpPr>
+        <p:spPr>
+          <a:xfrm>
+            <a:off x="1353312" y="5111496"/>
+            <a:ext cx="1179576" cy="274320"/>
+          </a:xfrm>
+          <a:prstGeom prst="rect">
+            <a:avLst/>
+          </a:prstGeom>
+          <a:noFill/>
+          <a:ln/>
+        </p:spPr>
+        <p:txBody>
+          <a:bodyPr wrap="square" lIns="635" tIns="635" rIns="635" bIns="635" rtlCol="0" anchor="ctr">
+            <a:normAutofit/>
+          </a:bodyPr>
+          <a:lstStyle/>
+          <a:p>
+            <a:pPr algn="ctr" indent="0" marL="0">
+              <a:buNone/>
+            </a:pPr>
+            <a:r>
+              <a:rPr lang="en-US" sz="1100" b="1" dirty="0">
+                <a:solidFill>
+                  <a:srgbClr val="7C3AED"/>
+                </a:solidFill>
+                <a:latin typeface="Microsoft JhengHei" pitchFamily="34" charset="0"/>
+                <a:ea typeface="Microsoft JhengHei" pitchFamily="34" charset="-122"/>
+                <a:cs typeface="Microsoft JhengHei" pitchFamily="34" charset="-120"/>
+              </a:rPr>
+              <a:t>重點字</a:t>
+            </a:r>
+            <a:endParaRPr lang="en-US" sz="1100" dirty="0"/>
+          </a:p>
+        </p:txBody>
+      </p:sp>
+      <p:sp>
+        <p:nvSpPr>
+          <p:cNvPr id="51" name="Text 49"/>
+          <p:cNvSpPr/>
+          <p:nvPr/>
+        </p:nvSpPr>
+        <p:spPr>
+          <a:xfrm>
+            <a:off x="2743200" y="5074920"/>
+            <a:ext cx="7452360" cy="310896"/>
+          </a:xfrm>
+          <a:prstGeom prst="rect">
+            <a:avLst/>
+          </a:prstGeom>
+          <a:noFill/>
+          <a:ln/>
+        </p:spPr>
+        <p:txBody>
+          <a:bodyPr wrap="square" lIns="635" tIns="635" rIns="635" bIns="635" rtlCol="0" anchor="ctr">
+            <a:normAutofit/>
+          </a:bodyPr>
+          <a:lstStyle/>
+          <a:p>
+            <a:pPr algn="l" indent="0" marL="0">
+              <a:buNone/>
+            </a:pPr>
+            <a:r>
+              <a:rPr lang="en-US" sz="1300" dirty="0">
+                <a:solidFill>
+                  <a:srgbClr val="163044"/>
+                </a:solidFill>
+                <a:latin typeface="Microsoft JhengHei" pitchFamily="34" charset="0"/>
+                <a:ea typeface="Microsoft JhengHei" pitchFamily="34" charset="-122"/>
+                <a:cs typeface="Microsoft JhengHei" pitchFamily="34" charset="-120"/>
+              </a:rPr>
+              <a:t>借出了、還有</a:t>
+            </a:r>
             <a:endParaRPr lang="en-US" sz="1300" dirty="0"/>
           </a:p>
         </p:txBody>
       </p:sp>
       <p:sp>
         <p:nvSpPr>
-          <p:cNvPr id="30" name="Text 28"/>
-          <p:cNvSpPr/>
-          <p:nvPr/>
-        </p:nvSpPr>
-        <p:spPr>
-          <a:xfrm>
-            <a:off x="2743200" y="2697480"/>
-            <a:ext cx="7452360" cy="420624"/>
+          <p:cNvPr id="52" name="Shape 50"/>
+          <p:cNvSpPr/>
+          <p:nvPr/>
+        </p:nvSpPr>
+        <p:spPr>
+          <a:xfrm>
+            <a:off x="1325880" y="5376672"/>
+            <a:ext cx="1234440" cy="310896"/>
+          </a:xfrm>
+          <a:prstGeom prst="roundRect">
+            <a:avLst/>
+          </a:prstGeom>
+          <a:solidFill>
+            <a:srgbClr val="F3E8FF"/>
+          </a:solidFill>
+          <a:ln w="21590">
+            <a:solidFill>
+              <a:srgbClr val="7C3AED"/>
+            </a:solidFill>
+            <a:prstDash val="solid"/>
+          </a:ln>
+        </p:spPr>
+      </p:sp>
+      <p:sp>
+        <p:nvSpPr>
+          <p:cNvPr id="53" name="Text 51"/>
+          <p:cNvSpPr/>
+          <p:nvPr/>
+        </p:nvSpPr>
+        <p:spPr>
+          <a:xfrm>
+            <a:off x="1353312" y="5394960"/>
+            <a:ext cx="1179576" cy="274320"/>
+          </a:xfrm>
+          <a:prstGeom prst="rect">
+            <a:avLst/>
+          </a:prstGeom>
+          <a:noFill/>
+          <a:ln/>
+        </p:spPr>
+        <p:txBody>
+          <a:bodyPr wrap="square" lIns="635" tIns="635" rIns="635" bIns="635" rtlCol="0" anchor="ctr">
+            <a:normAutofit/>
+          </a:bodyPr>
+          <a:lstStyle/>
+          <a:p>
+            <a:pPr algn="ctr" indent="0" marL="0">
+              <a:buNone/>
+            </a:pPr>
+            <a:r>
+              <a:rPr lang="en-US" sz="1100" b="1" dirty="0">
+                <a:solidFill>
+                  <a:srgbClr val="7C3AED"/>
+                </a:solidFill>
+                <a:latin typeface="Microsoft JhengHei" pitchFamily="34" charset="0"/>
+                <a:ea typeface="Microsoft JhengHei" pitchFamily="34" charset="-122"/>
+                <a:cs typeface="Microsoft JhengHei" pitchFamily="34" charset="-120"/>
+              </a:rPr>
+              <a:t>判斷</a:t>
+            </a:r>
+            <a:endParaRPr lang="en-US" sz="1100" dirty="0"/>
+          </a:p>
+        </p:txBody>
+      </p:sp>
+      <p:sp>
+        <p:nvSpPr>
+          <p:cNvPr id="54" name="Text 52"/>
+          <p:cNvSpPr/>
+          <p:nvPr/>
+        </p:nvSpPr>
+        <p:spPr>
+          <a:xfrm>
+            <a:off x="2743200" y="5358384"/>
+            <a:ext cx="7452360" cy="292608"/>
           </a:xfrm>
           <a:prstGeom prst="rect">
             <a:avLst/>
@@ -33432,7 +34288,7 @@
               <a:buNone/>
             </a:pPr>
             <a:r>
-              <a:rPr lang="en-US" sz="1500" dirty="0">
+              <a:rPr lang="en-US" sz="1250" dirty="0">
                 <a:solidFill>
                   <a:srgbClr val="163044"/>
                 </a:solidFill>
@@ -33440,21 +34296,21 @@
                 <a:ea typeface="Microsoft JhengHei" pitchFamily="34" charset="-122"/>
                 <a:cs typeface="Microsoft JhengHei" pitchFamily="34" charset="-120"/>
               </a:rPr>
-              <a:t>數量增加，用加法。</a:t>
-            </a:r>
-            <a:endParaRPr lang="en-US" sz="1500" dirty="0"/>
-          </a:p>
-        </p:txBody>
-      </p:sp>
-      <p:sp>
-        <p:nvSpPr>
-          <p:cNvPr id="31" name="Shape 29"/>
-          <p:cNvSpPr/>
-          <p:nvPr/>
-        </p:nvSpPr>
-        <p:spPr>
-          <a:xfrm>
-            <a:off x="1325880" y="3108960"/>
+              <a:t>數量減少，用減法。</a:t>
+            </a:r>
+            <a:endParaRPr lang="en-US" sz="1250" dirty="0"/>
+          </a:p>
+        </p:txBody>
+      </p:sp>
+      <p:sp>
+        <p:nvSpPr>
+          <p:cNvPr id="55" name="Shape 53"/>
+          <p:cNvSpPr/>
+          <p:nvPr/>
+        </p:nvSpPr>
+        <p:spPr>
+          <a:xfrm>
+            <a:off x="1325880" y="5650992"/>
             <a:ext cx="1234440" cy="310896"/>
           </a:xfrm>
           <a:prstGeom prst="roundRect">
@@ -33473,13 +34329,13 @@
       </p:sp>
       <p:sp>
         <p:nvSpPr>
-          <p:cNvPr id="32" name="Text 30"/>
-          <p:cNvSpPr/>
-          <p:nvPr/>
-        </p:nvSpPr>
-        <p:spPr>
-          <a:xfrm>
-            <a:off x="1353312" y="3127248"/>
+          <p:cNvPr id="56" name="Text 54"/>
+          <p:cNvSpPr/>
+          <p:nvPr/>
+        </p:nvSpPr>
+        <p:spPr>
+          <a:xfrm>
+            <a:off x="1353312" y="5669280"/>
             <a:ext cx="1179576" cy="274320"/>
           </a:xfrm>
           <a:prstGeom prst="rect">
@@ -33498,7 +34354,7 @@
               <a:buNone/>
             </a:pPr>
             <a:r>
-              <a:rPr lang="en-US" sz="1300" b="1" dirty="0">
+              <a:rPr lang="en-US" sz="1100" b="1" dirty="0">
                 <a:solidFill>
                   <a:srgbClr val="7C3AED"/>
                 </a:solidFill>
@@ -33508,20 +34364,20 @@
               </a:rPr>
               <a:t>算式</a:t>
             </a:r>
-            <a:endParaRPr lang="en-US" sz="1300" dirty="0"/>
-          </a:p>
-        </p:txBody>
-      </p:sp>
-      <p:sp>
-        <p:nvSpPr>
-          <p:cNvPr id="33" name="Text 31"/>
-          <p:cNvSpPr/>
-          <p:nvPr/>
-        </p:nvSpPr>
-        <p:spPr>
-          <a:xfrm>
-            <a:off x="2743200" y="3090672"/>
-            <a:ext cx="7452360" cy="420624"/>
+            <a:endParaRPr lang="en-US" sz="1100" dirty="0"/>
+          </a:p>
+        </p:txBody>
+      </p:sp>
+      <p:sp>
+        <p:nvSpPr>
+          <p:cNvPr id="57" name="Text 55"/>
+          <p:cNvSpPr/>
+          <p:nvPr/>
+        </p:nvSpPr>
+        <p:spPr>
+          <a:xfrm>
+            <a:off x="2743200" y="5632704"/>
+            <a:ext cx="7452360" cy="292608"/>
           </a:xfrm>
           <a:prstGeom prst="rect">
             <a:avLst/>
@@ -33539,7 +34395,7 @@
               <a:buNone/>
             </a:pPr>
             <a:r>
-              <a:rPr lang="en-US" sz="2000" b="1" dirty="0">
+              <a:rPr lang="en-US" sz="1550" b="1" dirty="0">
                 <a:solidFill>
                   <a:srgbClr val="7C3AED"/>
                 </a:solidFill>
@@ -33547,865 +34403,9 @@
                 <a:ea typeface="Microsoft JhengHei" pitchFamily="34" charset="-122"/>
                 <a:cs typeface="Microsoft JhengHei" pitchFamily="34" charset="-120"/>
               </a:rPr>
-              <a:t>12 ＋ 6 ＝ 18</a:t>
-            </a:r>
-            <a:endParaRPr lang="en-US" sz="2000" dirty="0"/>
-          </a:p>
-        </p:txBody>
-      </p:sp>
-      <p:sp>
-        <p:nvSpPr>
-          <p:cNvPr id="34" name="Shape 32"/>
-          <p:cNvSpPr/>
-          <p:nvPr/>
-        </p:nvSpPr>
-        <p:spPr>
-          <a:xfrm>
-            <a:off x="713232" y="4023360"/>
-            <a:ext cx="10332720" cy="1874520"/>
-          </a:xfrm>
-          <a:prstGeom prst="roundRect">
-            <a:avLst/>
-          </a:prstGeom>
-          <a:solidFill>
-            <a:srgbClr val="FFFFFF"/>
-          </a:solidFill>
-          <a:ln w="25400">
-            <a:solidFill>
-              <a:srgbClr val="DDD6FE"/>
-            </a:solidFill>
-            <a:prstDash val="solid"/>
-          </a:ln>
-        </p:spPr>
-      </p:sp>
-      <p:sp>
-        <p:nvSpPr>
-          <p:cNvPr id="35" name="Text 33"/>
-          <p:cNvSpPr/>
-          <p:nvPr/>
-        </p:nvSpPr>
-        <p:spPr>
-          <a:xfrm>
-            <a:off x="896112" y="4279392"/>
-            <a:ext cx="384048" cy="384048"/>
-          </a:xfrm>
-          <a:prstGeom prst="rect">
-            <a:avLst/>
-          </a:prstGeom>
-          <a:noFill/>
-          <a:ln/>
-        </p:spPr>
-        <p:txBody>
-          <a:bodyPr wrap="square" lIns="635" tIns="635" rIns="635" bIns="635" rtlCol="0" anchor="ctr">
-            <a:normAutofit/>
-          </a:bodyPr>
-          <a:lstStyle/>
-          <a:p>
-            <a:pPr algn="ctr" indent="0" marL="0">
-              <a:buNone/>
-            </a:pPr>
-            <a:r>
-              <a:rPr lang="en-US" sz="2600" b="1" dirty="0">
-                <a:solidFill>
-                  <a:srgbClr val="166534"/>
-                </a:solidFill>
-                <a:latin typeface="Microsoft JhengHei" pitchFamily="34" charset="0"/>
-                <a:ea typeface="Microsoft JhengHei" pitchFamily="34" charset="-122"/>
-                <a:cs typeface="Microsoft JhengHei" pitchFamily="34" charset="-120"/>
-              </a:rPr>
-              <a:t>✓</a:t>
-            </a:r>
-            <a:endParaRPr lang="en-US" sz="2600" dirty="0"/>
-          </a:p>
-        </p:txBody>
-      </p:sp>
-      <p:sp>
-        <p:nvSpPr>
-          <p:cNvPr id="36" name="Text 34"/>
-          <p:cNvSpPr/>
-          <p:nvPr/>
-        </p:nvSpPr>
-        <p:spPr>
-          <a:xfrm>
-            <a:off x="1325880" y="4233672"/>
-            <a:ext cx="1005840" cy="320040"/>
-          </a:xfrm>
-          <a:prstGeom prst="rect">
-            <a:avLst/>
-          </a:prstGeom>
-          <a:noFill/>
-          <a:ln/>
-        </p:spPr>
-        <p:txBody>
-          <a:bodyPr wrap="square" lIns="635" tIns="635" rIns="635" bIns="635" rtlCol="0" anchor="ctr">
-            <a:normAutofit/>
-          </a:bodyPr>
-          <a:lstStyle/>
-          <a:p>
-            <a:pPr algn="l" indent="0" marL="0">
-              <a:buNone/>
-            </a:pPr>
-            <a:r>
-              <a:rPr lang="en-US" sz="1900" b="1" dirty="0">
-                <a:solidFill>
-                  <a:srgbClr val="7C3AED"/>
-                </a:solidFill>
-                <a:latin typeface="Microsoft JhengHei" pitchFamily="34" charset="0"/>
-                <a:ea typeface="Microsoft JhengHei" pitchFamily="34" charset="-122"/>
-                <a:cs typeface="Microsoft JhengHei" pitchFamily="34" charset="-120"/>
-              </a:rPr>
-              <a:t>題目 B</a:t>
-            </a:r>
-            <a:endParaRPr lang="en-US" sz="1900" dirty="0"/>
-          </a:p>
-        </p:txBody>
-      </p:sp>
-      <p:sp>
-        <p:nvSpPr>
-          <p:cNvPr id="37" name="Shape 35"/>
-          <p:cNvSpPr/>
-          <p:nvPr/>
-        </p:nvSpPr>
-        <p:spPr>
-          <a:xfrm>
-            <a:off x="1325880" y="4645152"/>
-            <a:ext cx="1234440" cy="310896"/>
-          </a:xfrm>
-          <a:prstGeom prst="roundRect">
-            <a:avLst/>
-          </a:prstGeom>
-          <a:solidFill>
-            <a:srgbClr val="F3E8FF"/>
-          </a:solidFill>
-          <a:ln w="21590">
-            <a:solidFill>
-              <a:srgbClr val="7C3AED"/>
-            </a:solidFill>
-            <a:prstDash val="solid"/>
-          </a:ln>
-        </p:spPr>
-      </p:sp>
-      <p:sp>
-        <p:nvSpPr>
-          <p:cNvPr id="38" name="Text 36"/>
-          <p:cNvSpPr/>
-          <p:nvPr/>
-        </p:nvSpPr>
-        <p:spPr>
-          <a:xfrm>
-            <a:off x="1353312" y="4663440"/>
-            <a:ext cx="1179576" cy="274320"/>
-          </a:xfrm>
-          <a:prstGeom prst="rect">
-            <a:avLst/>
-          </a:prstGeom>
-          <a:noFill/>
-          <a:ln/>
-        </p:spPr>
-        <p:txBody>
-          <a:bodyPr wrap="square" lIns="635" tIns="635" rIns="635" bIns="635" rtlCol="0" anchor="ctr">
-            <a:normAutofit/>
-          </a:bodyPr>
-          <a:lstStyle/>
-          <a:p>
-            <a:pPr algn="ctr" indent="0" marL="0">
-              <a:buNone/>
-            </a:pPr>
-            <a:r>
-              <a:rPr lang="en-US" sz="1300" b="1" dirty="0">
-                <a:solidFill>
-                  <a:srgbClr val="7C3AED"/>
-                </a:solidFill>
-                <a:latin typeface="Microsoft JhengHei" pitchFamily="34" charset="0"/>
-                <a:ea typeface="Microsoft JhengHei" pitchFamily="34" charset="-122"/>
-                <a:cs typeface="Microsoft JhengHei" pitchFamily="34" charset="-120"/>
-              </a:rPr>
-              <a:t>重點字</a:t>
-            </a:r>
-            <a:endParaRPr lang="en-US" sz="1300" dirty="0"/>
-          </a:p>
-        </p:txBody>
-      </p:sp>
-      <p:sp>
-        <p:nvSpPr>
-          <p:cNvPr id="39" name="Text 37"/>
-          <p:cNvSpPr/>
-          <p:nvPr/>
-        </p:nvSpPr>
-        <p:spPr>
-          <a:xfrm>
-            <a:off x="2743200" y="4626864"/>
-            <a:ext cx="7452360" cy="420624"/>
-          </a:xfrm>
-          <a:prstGeom prst="rect">
-            <a:avLst/>
-          </a:prstGeom>
-          <a:noFill/>
-          <a:ln/>
-        </p:spPr>
-        <p:txBody>
-          <a:bodyPr wrap="square" lIns="635" tIns="635" rIns="635" bIns="635" rtlCol="0" anchor="ctr">
-            <a:normAutofit/>
-          </a:bodyPr>
-          <a:lstStyle/>
-          <a:p>
-            <a:pPr algn="l" indent="0" marL="0">
-              <a:buNone/>
-            </a:pPr>
-            <a:r>
-              <a:rPr lang="en-US" sz="1600" dirty="0">
-                <a:solidFill>
-                  <a:srgbClr val="163044"/>
-                </a:solidFill>
-                <a:latin typeface="Microsoft JhengHei" pitchFamily="34" charset="0"/>
-                <a:ea typeface="Microsoft JhengHei" pitchFamily="34" charset="-122"/>
-                <a:cs typeface="Microsoft JhengHei" pitchFamily="34" charset="-120"/>
-              </a:rPr>
-              <a:t>每包、有 5 包</a:t>
-            </a:r>
-            <a:endParaRPr lang="en-US" sz="1600" dirty="0"/>
-          </a:p>
-        </p:txBody>
-      </p:sp>
-      <p:sp>
-        <p:nvSpPr>
-          <p:cNvPr id="40" name="Shape 38"/>
-          <p:cNvSpPr/>
-          <p:nvPr/>
-        </p:nvSpPr>
-        <p:spPr>
-          <a:xfrm>
-            <a:off x="1325880" y="5047488"/>
-            <a:ext cx="1234440" cy="310896"/>
-          </a:xfrm>
-          <a:prstGeom prst="roundRect">
-            <a:avLst/>
-          </a:prstGeom>
-          <a:solidFill>
-            <a:srgbClr val="F3E8FF"/>
-          </a:solidFill>
-          <a:ln w="21590">
-            <a:solidFill>
-              <a:srgbClr val="7C3AED"/>
-            </a:solidFill>
-            <a:prstDash val="solid"/>
-          </a:ln>
-        </p:spPr>
-      </p:sp>
-      <p:sp>
-        <p:nvSpPr>
-          <p:cNvPr id="41" name="Text 39"/>
-          <p:cNvSpPr/>
-          <p:nvPr/>
-        </p:nvSpPr>
-        <p:spPr>
-          <a:xfrm>
-            <a:off x="1353312" y="5065776"/>
-            <a:ext cx="1179576" cy="274320"/>
-          </a:xfrm>
-          <a:prstGeom prst="rect">
-            <a:avLst/>
-          </a:prstGeom>
-          <a:noFill/>
-          <a:ln/>
-        </p:spPr>
-        <p:txBody>
-          <a:bodyPr wrap="square" lIns="635" tIns="635" rIns="635" bIns="635" rtlCol="0" anchor="ctr">
-            <a:normAutofit/>
-          </a:bodyPr>
-          <a:lstStyle/>
-          <a:p>
-            <a:pPr algn="ctr" indent="0" marL="0">
-              <a:buNone/>
-            </a:pPr>
-            <a:r>
-              <a:rPr lang="en-US" sz="1300" b="1" dirty="0">
-                <a:solidFill>
-                  <a:srgbClr val="7C3AED"/>
-                </a:solidFill>
-                <a:latin typeface="Microsoft JhengHei" pitchFamily="34" charset="0"/>
-                <a:ea typeface="Microsoft JhengHei" pitchFamily="34" charset="-122"/>
-                <a:cs typeface="Microsoft JhengHei" pitchFamily="34" charset="-120"/>
-              </a:rPr>
-              <a:t>判斷</a:t>
-            </a:r>
-            <a:endParaRPr lang="en-US" sz="1300" dirty="0"/>
-          </a:p>
-        </p:txBody>
-      </p:sp>
-      <p:sp>
-        <p:nvSpPr>
-          <p:cNvPr id="42" name="Text 40"/>
-          <p:cNvSpPr/>
-          <p:nvPr/>
-        </p:nvSpPr>
-        <p:spPr>
-          <a:xfrm>
-            <a:off x="2743200" y="5029200"/>
-            <a:ext cx="7452360" cy="420624"/>
-          </a:xfrm>
-          <a:prstGeom prst="rect">
-            <a:avLst/>
-          </a:prstGeom>
-          <a:noFill/>
-          <a:ln/>
-        </p:spPr>
-        <p:txBody>
-          <a:bodyPr wrap="square" lIns="635" tIns="635" rIns="635" bIns="635" rtlCol="0" anchor="ctr">
-            <a:normAutofit/>
-          </a:bodyPr>
-          <a:lstStyle/>
-          <a:p>
-            <a:pPr algn="l" indent="0" marL="0">
-              <a:buNone/>
-            </a:pPr>
-            <a:r>
-              <a:rPr lang="en-US" sz="1500" dirty="0">
-                <a:solidFill>
-                  <a:srgbClr val="163044"/>
-                </a:solidFill>
-                <a:latin typeface="Microsoft JhengHei" pitchFamily="34" charset="0"/>
-                <a:ea typeface="Microsoft JhengHei" pitchFamily="34" charset="-122"/>
-                <a:cs typeface="Microsoft JhengHei" pitchFamily="34" charset="-120"/>
-              </a:rPr>
-              <a:t>相同組數，用乘法。</a:t>
-            </a:r>
-            <a:endParaRPr lang="en-US" sz="1500" dirty="0"/>
-          </a:p>
-        </p:txBody>
-      </p:sp>
-      <p:sp>
-        <p:nvSpPr>
-          <p:cNvPr id="43" name="Shape 41"/>
-          <p:cNvSpPr/>
-          <p:nvPr/>
-        </p:nvSpPr>
-        <p:spPr>
-          <a:xfrm>
-            <a:off x="1325880" y="5440680"/>
-            <a:ext cx="1234440" cy="310896"/>
-          </a:xfrm>
-          <a:prstGeom prst="roundRect">
-            <a:avLst/>
-          </a:prstGeom>
-          <a:solidFill>
-            <a:srgbClr val="F3E8FF"/>
-          </a:solidFill>
-          <a:ln w="21590">
-            <a:solidFill>
-              <a:srgbClr val="7C3AED"/>
-            </a:solidFill>
-            <a:prstDash val="solid"/>
-          </a:ln>
-        </p:spPr>
-      </p:sp>
-      <p:sp>
-        <p:nvSpPr>
-          <p:cNvPr id="44" name="Text 42"/>
-          <p:cNvSpPr/>
-          <p:nvPr/>
-        </p:nvSpPr>
-        <p:spPr>
-          <a:xfrm>
-            <a:off x="1353312" y="5458968"/>
-            <a:ext cx="1179576" cy="274320"/>
-          </a:xfrm>
-          <a:prstGeom prst="rect">
-            <a:avLst/>
-          </a:prstGeom>
-          <a:noFill/>
-          <a:ln/>
-        </p:spPr>
-        <p:txBody>
-          <a:bodyPr wrap="square" lIns="635" tIns="635" rIns="635" bIns="635" rtlCol="0" anchor="ctr">
-            <a:normAutofit/>
-          </a:bodyPr>
-          <a:lstStyle/>
-          <a:p>
-            <a:pPr algn="ctr" indent="0" marL="0">
-              <a:buNone/>
-            </a:pPr>
-            <a:r>
-              <a:rPr lang="en-US" sz="1300" b="1" dirty="0">
-                <a:solidFill>
-                  <a:srgbClr val="7C3AED"/>
-                </a:solidFill>
-                <a:latin typeface="Microsoft JhengHei" pitchFamily="34" charset="0"/>
-                <a:ea typeface="Microsoft JhengHei" pitchFamily="34" charset="-122"/>
-                <a:cs typeface="Microsoft JhengHei" pitchFamily="34" charset="-120"/>
-              </a:rPr>
-              <a:t>算式</a:t>
-            </a:r>
-            <a:endParaRPr lang="en-US" sz="1300" dirty="0"/>
-          </a:p>
-        </p:txBody>
-      </p:sp>
-      <p:sp>
-        <p:nvSpPr>
-          <p:cNvPr id="45" name="Text 43"/>
-          <p:cNvSpPr/>
-          <p:nvPr/>
-        </p:nvSpPr>
-        <p:spPr>
-          <a:xfrm>
-            <a:off x="2743200" y="5422392"/>
-            <a:ext cx="7452360" cy="420624"/>
-          </a:xfrm>
-          <a:prstGeom prst="rect">
-            <a:avLst/>
-          </a:prstGeom>
-          <a:noFill/>
-          <a:ln/>
-        </p:spPr>
-        <p:txBody>
-          <a:bodyPr wrap="square" lIns="635" tIns="635" rIns="635" bIns="635" rtlCol="0" anchor="ctr">
-            <a:normAutofit/>
-          </a:bodyPr>
-          <a:lstStyle/>
-          <a:p>
-            <a:pPr algn="l" indent="0" marL="0">
-              <a:buNone/>
-            </a:pPr>
-            <a:r>
-              <a:rPr lang="en-US" sz="2000" b="1" dirty="0">
-                <a:solidFill>
-                  <a:srgbClr val="7C3AED"/>
-                </a:solidFill>
-                <a:latin typeface="Microsoft JhengHei" pitchFamily="34" charset="0"/>
-                <a:ea typeface="Microsoft JhengHei" pitchFamily="34" charset="-122"/>
-                <a:cs typeface="Microsoft JhengHei" pitchFamily="34" charset="-120"/>
-              </a:rPr>
-              <a:t>6 × 5 ＝ 30</a:t>
-            </a:r>
-            <a:endParaRPr lang="en-US" sz="2000" dirty="0"/>
-          </a:p>
-        </p:txBody>
-      </p:sp>
-      <p:sp>
-        <p:nvSpPr>
-          <p:cNvPr id="46" name="Shape 44"/>
-          <p:cNvSpPr/>
-          <p:nvPr/>
-        </p:nvSpPr>
-        <p:spPr>
-          <a:xfrm>
-            <a:off x="713232" y="6355080"/>
-            <a:ext cx="10332720" cy="1874520"/>
-          </a:xfrm>
-          <a:prstGeom prst="roundRect">
-            <a:avLst/>
-          </a:prstGeom>
-          <a:solidFill>
-            <a:srgbClr val="FFFFFF"/>
-          </a:solidFill>
-          <a:ln w="25400">
-            <a:solidFill>
-              <a:srgbClr val="DDD6FE"/>
-            </a:solidFill>
-            <a:prstDash val="solid"/>
-          </a:ln>
-        </p:spPr>
-      </p:sp>
-      <p:sp>
-        <p:nvSpPr>
-          <p:cNvPr id="47" name="Text 45"/>
-          <p:cNvSpPr/>
-          <p:nvPr/>
-        </p:nvSpPr>
-        <p:spPr>
-          <a:xfrm>
-            <a:off x="896112" y="6611112"/>
-            <a:ext cx="384048" cy="384048"/>
-          </a:xfrm>
-          <a:prstGeom prst="rect">
-            <a:avLst/>
-          </a:prstGeom>
-          <a:noFill/>
-          <a:ln/>
-        </p:spPr>
-        <p:txBody>
-          <a:bodyPr wrap="square" lIns="635" tIns="635" rIns="635" bIns="635" rtlCol="0" anchor="ctr">
-            <a:normAutofit/>
-          </a:bodyPr>
-          <a:lstStyle/>
-          <a:p>
-            <a:pPr algn="ctr" indent="0" marL="0">
-              <a:buNone/>
-            </a:pPr>
-            <a:r>
-              <a:rPr lang="en-US" sz="2600" b="1" dirty="0">
-                <a:solidFill>
-                  <a:srgbClr val="166534"/>
-                </a:solidFill>
-                <a:latin typeface="Microsoft JhengHei" pitchFamily="34" charset="0"/>
-                <a:ea typeface="Microsoft JhengHei" pitchFamily="34" charset="-122"/>
-                <a:cs typeface="Microsoft JhengHei" pitchFamily="34" charset="-120"/>
-              </a:rPr>
-              <a:t>✓</a:t>
-            </a:r>
-            <a:endParaRPr lang="en-US" sz="2600" dirty="0"/>
-          </a:p>
-        </p:txBody>
-      </p:sp>
-      <p:sp>
-        <p:nvSpPr>
-          <p:cNvPr id="48" name="Text 46"/>
-          <p:cNvSpPr/>
-          <p:nvPr/>
-        </p:nvSpPr>
-        <p:spPr>
-          <a:xfrm>
-            <a:off x="1325880" y="6565392"/>
-            <a:ext cx="1005840" cy="320040"/>
-          </a:xfrm>
-          <a:prstGeom prst="rect">
-            <a:avLst/>
-          </a:prstGeom>
-          <a:noFill/>
-          <a:ln/>
-        </p:spPr>
-        <p:txBody>
-          <a:bodyPr wrap="square" lIns="635" tIns="635" rIns="635" bIns="635" rtlCol="0" anchor="ctr">
-            <a:normAutofit/>
-          </a:bodyPr>
-          <a:lstStyle/>
-          <a:p>
-            <a:pPr algn="l" indent="0" marL="0">
-              <a:buNone/>
-            </a:pPr>
-            <a:r>
-              <a:rPr lang="en-US" sz="1900" b="1" dirty="0">
-                <a:solidFill>
-                  <a:srgbClr val="7C3AED"/>
-                </a:solidFill>
-                <a:latin typeface="Microsoft JhengHei" pitchFamily="34" charset="0"/>
-                <a:ea typeface="Microsoft JhengHei" pitchFamily="34" charset="-122"/>
-                <a:cs typeface="Microsoft JhengHei" pitchFamily="34" charset="-120"/>
-              </a:rPr>
-              <a:t>題目 C</a:t>
-            </a:r>
-            <a:endParaRPr lang="en-US" sz="1900" dirty="0"/>
-          </a:p>
-        </p:txBody>
-      </p:sp>
-      <p:sp>
-        <p:nvSpPr>
-          <p:cNvPr id="49" name="Shape 47"/>
-          <p:cNvSpPr/>
-          <p:nvPr/>
-        </p:nvSpPr>
-        <p:spPr>
-          <a:xfrm>
-            <a:off x="1325880" y="6976872"/>
-            <a:ext cx="1234440" cy="310896"/>
-          </a:xfrm>
-          <a:prstGeom prst="roundRect">
-            <a:avLst/>
-          </a:prstGeom>
-          <a:solidFill>
-            <a:srgbClr val="F3E8FF"/>
-          </a:solidFill>
-          <a:ln w="21590">
-            <a:solidFill>
-              <a:srgbClr val="7C3AED"/>
-            </a:solidFill>
-            <a:prstDash val="solid"/>
-          </a:ln>
-        </p:spPr>
-      </p:sp>
-      <p:sp>
-        <p:nvSpPr>
-          <p:cNvPr id="50" name="Text 48"/>
-          <p:cNvSpPr/>
-          <p:nvPr/>
-        </p:nvSpPr>
-        <p:spPr>
-          <a:xfrm>
-            <a:off x="1353312" y="6995160"/>
-            <a:ext cx="1179576" cy="274320"/>
-          </a:xfrm>
-          <a:prstGeom prst="rect">
-            <a:avLst/>
-          </a:prstGeom>
-          <a:noFill/>
-          <a:ln/>
-        </p:spPr>
-        <p:txBody>
-          <a:bodyPr wrap="square" lIns="635" tIns="635" rIns="635" bIns="635" rtlCol="0" anchor="ctr">
-            <a:normAutofit/>
-          </a:bodyPr>
-          <a:lstStyle/>
-          <a:p>
-            <a:pPr algn="ctr" indent="0" marL="0">
-              <a:buNone/>
-            </a:pPr>
-            <a:r>
-              <a:rPr lang="en-US" sz="1300" b="1" dirty="0">
-                <a:solidFill>
-                  <a:srgbClr val="7C3AED"/>
-                </a:solidFill>
-                <a:latin typeface="Microsoft JhengHei" pitchFamily="34" charset="0"/>
-                <a:ea typeface="Microsoft JhengHei" pitchFamily="34" charset="-122"/>
-                <a:cs typeface="Microsoft JhengHei" pitchFamily="34" charset="-120"/>
-              </a:rPr>
-              <a:t>重點字</a:t>
-            </a:r>
-            <a:endParaRPr lang="en-US" sz="1300" dirty="0"/>
-          </a:p>
-        </p:txBody>
-      </p:sp>
-      <p:sp>
-        <p:nvSpPr>
-          <p:cNvPr id="51" name="Text 49"/>
-          <p:cNvSpPr/>
-          <p:nvPr/>
-        </p:nvSpPr>
-        <p:spPr>
-          <a:xfrm>
-            <a:off x="2743200" y="6958584"/>
-            <a:ext cx="7452360" cy="420624"/>
-          </a:xfrm>
-          <a:prstGeom prst="rect">
-            <a:avLst/>
-          </a:prstGeom>
-          <a:noFill/>
-          <a:ln/>
-        </p:spPr>
-        <p:txBody>
-          <a:bodyPr wrap="square" lIns="635" tIns="635" rIns="635" bIns="635" rtlCol="0" anchor="ctr">
-            <a:normAutofit/>
-          </a:bodyPr>
-          <a:lstStyle/>
-          <a:p>
-            <a:pPr algn="l" indent="0" marL="0">
-              <a:buNone/>
-            </a:pPr>
-            <a:r>
-              <a:rPr lang="en-US" sz="1600" dirty="0">
-                <a:solidFill>
-                  <a:srgbClr val="163044"/>
-                </a:solidFill>
-                <a:latin typeface="Microsoft JhengHei" pitchFamily="34" charset="0"/>
-                <a:ea typeface="Microsoft JhengHei" pitchFamily="34" charset="-122"/>
-                <a:cs typeface="Microsoft JhengHei" pitchFamily="34" charset="-120"/>
-              </a:rPr>
-              <a:t>借出了、還有</a:t>
-            </a:r>
-            <a:endParaRPr lang="en-US" sz="1600" dirty="0"/>
-          </a:p>
-        </p:txBody>
-      </p:sp>
-      <p:sp>
-        <p:nvSpPr>
-          <p:cNvPr id="52" name="Shape 50"/>
-          <p:cNvSpPr/>
-          <p:nvPr/>
-        </p:nvSpPr>
-        <p:spPr>
-          <a:xfrm>
-            <a:off x="1325880" y="7379208"/>
-            <a:ext cx="1234440" cy="310896"/>
-          </a:xfrm>
-          <a:prstGeom prst="roundRect">
-            <a:avLst/>
-          </a:prstGeom>
-          <a:solidFill>
-            <a:srgbClr val="F3E8FF"/>
-          </a:solidFill>
-          <a:ln w="21590">
-            <a:solidFill>
-              <a:srgbClr val="7C3AED"/>
-            </a:solidFill>
-            <a:prstDash val="solid"/>
-          </a:ln>
-        </p:spPr>
-      </p:sp>
-      <p:sp>
-        <p:nvSpPr>
-          <p:cNvPr id="53" name="Text 51"/>
-          <p:cNvSpPr/>
-          <p:nvPr/>
-        </p:nvSpPr>
-        <p:spPr>
-          <a:xfrm>
-            <a:off x="1353312" y="7397496"/>
-            <a:ext cx="1179576" cy="274320"/>
-          </a:xfrm>
-          <a:prstGeom prst="rect">
-            <a:avLst/>
-          </a:prstGeom>
-          <a:noFill/>
-          <a:ln/>
-        </p:spPr>
-        <p:txBody>
-          <a:bodyPr wrap="square" lIns="635" tIns="635" rIns="635" bIns="635" rtlCol="0" anchor="ctr">
-            <a:normAutofit/>
-          </a:bodyPr>
-          <a:lstStyle/>
-          <a:p>
-            <a:pPr algn="ctr" indent="0" marL="0">
-              <a:buNone/>
-            </a:pPr>
-            <a:r>
-              <a:rPr lang="en-US" sz="1300" b="1" dirty="0">
-                <a:solidFill>
-                  <a:srgbClr val="7C3AED"/>
-                </a:solidFill>
-                <a:latin typeface="Microsoft JhengHei" pitchFamily="34" charset="0"/>
-                <a:ea typeface="Microsoft JhengHei" pitchFamily="34" charset="-122"/>
-                <a:cs typeface="Microsoft JhengHei" pitchFamily="34" charset="-120"/>
-              </a:rPr>
-              <a:t>判斷</a:t>
-            </a:r>
-            <a:endParaRPr lang="en-US" sz="1300" dirty="0"/>
-          </a:p>
-        </p:txBody>
-      </p:sp>
-      <p:sp>
-        <p:nvSpPr>
-          <p:cNvPr id="54" name="Text 52"/>
-          <p:cNvSpPr/>
-          <p:nvPr/>
-        </p:nvSpPr>
-        <p:spPr>
-          <a:xfrm>
-            <a:off x="2743200" y="7360920"/>
-            <a:ext cx="7452360" cy="420624"/>
-          </a:xfrm>
-          <a:prstGeom prst="rect">
-            <a:avLst/>
-          </a:prstGeom>
-          <a:noFill/>
-          <a:ln/>
-        </p:spPr>
-        <p:txBody>
-          <a:bodyPr wrap="square" lIns="635" tIns="635" rIns="635" bIns="635" rtlCol="0" anchor="ctr">
-            <a:normAutofit/>
-          </a:bodyPr>
-          <a:lstStyle/>
-          <a:p>
-            <a:pPr algn="l" indent="0" marL="0">
-              <a:buNone/>
-            </a:pPr>
-            <a:r>
-              <a:rPr lang="en-US" sz="1500" dirty="0">
-                <a:solidFill>
-                  <a:srgbClr val="163044"/>
-                </a:solidFill>
-                <a:latin typeface="Microsoft JhengHei" pitchFamily="34" charset="0"/>
-                <a:ea typeface="Microsoft JhengHei" pitchFamily="34" charset="-122"/>
-                <a:cs typeface="Microsoft JhengHei" pitchFamily="34" charset="-120"/>
-              </a:rPr>
-              <a:t>數量減少，用減法。</a:t>
-            </a:r>
-            <a:endParaRPr lang="en-US" sz="1500" dirty="0"/>
-          </a:p>
-        </p:txBody>
-      </p:sp>
-      <p:sp>
-        <p:nvSpPr>
-          <p:cNvPr id="55" name="Shape 53"/>
-          <p:cNvSpPr/>
-          <p:nvPr/>
-        </p:nvSpPr>
-        <p:spPr>
-          <a:xfrm>
-            <a:off x="1325880" y="7772400"/>
-            <a:ext cx="1234440" cy="310896"/>
-          </a:xfrm>
-          <a:prstGeom prst="roundRect">
-            <a:avLst/>
-          </a:prstGeom>
-          <a:solidFill>
-            <a:srgbClr val="F3E8FF"/>
-          </a:solidFill>
-          <a:ln w="21590">
-            <a:solidFill>
-              <a:srgbClr val="7C3AED"/>
-            </a:solidFill>
-            <a:prstDash val="solid"/>
-          </a:ln>
-        </p:spPr>
-      </p:sp>
-      <p:sp>
-        <p:nvSpPr>
-          <p:cNvPr id="56" name="Text 54"/>
-          <p:cNvSpPr/>
-          <p:nvPr/>
-        </p:nvSpPr>
-        <p:spPr>
-          <a:xfrm>
-            <a:off x="1353312" y="7790688"/>
-            <a:ext cx="1179576" cy="274320"/>
-          </a:xfrm>
-          <a:prstGeom prst="rect">
-            <a:avLst/>
-          </a:prstGeom>
-          <a:noFill/>
-          <a:ln/>
-        </p:spPr>
-        <p:txBody>
-          <a:bodyPr wrap="square" lIns="635" tIns="635" rIns="635" bIns="635" rtlCol="0" anchor="ctr">
-            <a:normAutofit/>
-          </a:bodyPr>
-          <a:lstStyle/>
-          <a:p>
-            <a:pPr algn="ctr" indent="0" marL="0">
-              <a:buNone/>
-            </a:pPr>
-            <a:r>
-              <a:rPr lang="en-US" sz="1300" b="1" dirty="0">
-                <a:solidFill>
-                  <a:srgbClr val="7C3AED"/>
-                </a:solidFill>
-                <a:latin typeface="Microsoft JhengHei" pitchFamily="34" charset="0"/>
-                <a:ea typeface="Microsoft JhengHei" pitchFamily="34" charset="-122"/>
-                <a:cs typeface="Microsoft JhengHei" pitchFamily="34" charset="-120"/>
-              </a:rPr>
-              <a:t>算式</a:t>
-            </a:r>
-            <a:endParaRPr lang="en-US" sz="1300" dirty="0"/>
-          </a:p>
-        </p:txBody>
-      </p:sp>
-      <p:sp>
-        <p:nvSpPr>
-          <p:cNvPr id="57" name="Text 55"/>
-          <p:cNvSpPr/>
-          <p:nvPr/>
-        </p:nvSpPr>
-        <p:spPr>
-          <a:xfrm>
-            <a:off x="2743200" y="7754112"/>
-            <a:ext cx="7452360" cy="420624"/>
-          </a:xfrm>
-          <a:prstGeom prst="rect">
-            <a:avLst/>
-          </a:prstGeom>
-          <a:noFill/>
-          <a:ln/>
-        </p:spPr>
-        <p:txBody>
-          <a:bodyPr wrap="square" lIns="635" tIns="635" rIns="635" bIns="635" rtlCol="0" anchor="ctr">
-            <a:normAutofit/>
-          </a:bodyPr>
-          <a:lstStyle/>
-          <a:p>
-            <a:pPr algn="l" indent="0" marL="0">
-              <a:buNone/>
-            </a:pPr>
-            <a:r>
-              <a:rPr lang="en-US" sz="2000" b="1" dirty="0">
-                <a:solidFill>
-                  <a:srgbClr val="7C3AED"/>
-                </a:solidFill>
-                <a:latin typeface="Microsoft JhengHei" pitchFamily="34" charset="0"/>
-                <a:ea typeface="Microsoft JhengHei" pitchFamily="34" charset="-122"/>
-                <a:cs typeface="Microsoft JhengHei" pitchFamily="34" charset="-120"/>
-              </a:rPr>
               <a:t>30 － 12 ＝ 18</a:t>
             </a:r>
-            <a:endParaRPr lang="en-US" sz="2000" dirty="0"/>
+            <a:endParaRPr lang="en-US" sz="1550" dirty="0"/>
           </a:p>
         </p:txBody>
       </p:sp>
@@ -37292,8 +37292,8 @@
         </p:nvSpPr>
         <p:spPr>
           <a:xfrm>
-            <a:off x="713232" y="1691640"/>
-            <a:ext cx="10332720" cy="1874520"/>
+            <a:off x="713232" y="1572768"/>
+            <a:ext cx="10332720" cy="1261872"/>
           </a:xfrm>
           <a:prstGeom prst="roundRect">
             <a:avLst/>
@@ -37317,8 +37317,8 @@
         </p:nvSpPr>
         <p:spPr>
           <a:xfrm>
-            <a:off x="896112" y="1947672"/>
-            <a:ext cx="384048" cy="384048"/>
+            <a:off x="896112" y="1700784"/>
+            <a:ext cx="314919" cy="314919"/>
           </a:xfrm>
           <a:prstGeom prst="rect">
             <a:avLst/>
@@ -37336,7 +37336,7 @@
               <a:buNone/>
             </a:pPr>
             <a:r>
-              <a:rPr lang="en-US" sz="2600" b="1" dirty="0">
+              <a:rPr lang="en-US" sz="2132" b="1" dirty="0">
                 <a:solidFill>
                   <a:srgbClr val="166534"/>
                 </a:solidFill>
@@ -37346,7 +37346,7 @@
               </a:rPr>
               <a:t>✓</a:t>
             </a:r>
-            <a:endParaRPr lang="en-US" sz="2600" dirty="0"/>
+            <a:endParaRPr lang="en-US" sz="2132" dirty="0"/>
           </a:p>
         </p:txBody>
       </p:sp>
@@ -37358,8 +37358,8 @@
         </p:nvSpPr>
         <p:spPr>
           <a:xfrm>
-            <a:off x="1325880" y="1901952"/>
-            <a:ext cx="1005840" cy="320040"/>
+            <a:off x="1325880" y="1709928"/>
+            <a:ext cx="1005840" cy="292608"/>
           </a:xfrm>
           <a:prstGeom prst="rect">
             <a:avLst/>
@@ -37377,7 +37377,7 @@
               <a:buNone/>
             </a:pPr>
             <a:r>
-              <a:rPr lang="en-US" sz="1900" b="1" dirty="0">
+              <a:rPr lang="en-US" sz="1600" b="1" dirty="0">
                 <a:solidFill>
                   <a:srgbClr val="7C3AED"/>
                 </a:solidFill>
@@ -37387,7 +37387,7 @@
               </a:rPr>
               <a:t>題目 A</a:t>
             </a:r>
-            <a:endParaRPr lang="en-US" sz="1900" dirty="0"/>
+            <a:endParaRPr lang="en-US" sz="1600" dirty="0"/>
           </a:p>
         </p:txBody>
       </p:sp>
@@ -37399,7 +37399,7 @@
         </p:nvSpPr>
         <p:spPr>
           <a:xfrm>
-            <a:off x="1325880" y="2313432"/>
+            <a:off x="1325880" y="2020824"/>
             <a:ext cx="1234440" cy="310896"/>
           </a:xfrm>
           <a:prstGeom prst="roundRect">
@@ -37424,7 +37424,7 @@
         </p:nvSpPr>
         <p:spPr>
           <a:xfrm>
-            <a:off x="1353312" y="2331720"/>
+            <a:off x="1353312" y="2039112"/>
             <a:ext cx="1179576" cy="274320"/>
           </a:xfrm>
           <a:prstGeom prst="rect">
@@ -37443,7 +37443,7 @@
               <a:buNone/>
             </a:pPr>
             <a:r>
-              <a:rPr lang="en-US" sz="1300" b="1" dirty="0">
+              <a:rPr lang="en-US" sz="1100" b="1" dirty="0">
                 <a:solidFill>
                   <a:srgbClr val="7C3AED"/>
                 </a:solidFill>
@@ -37453,20 +37453,127 @@
               </a:rPr>
               <a:t>重點字</a:t>
             </a:r>
+            <a:endParaRPr lang="en-US" sz="1100" dirty="0"/>
+          </a:p>
+        </p:txBody>
+      </p:sp>
+      <p:sp>
+        <p:nvSpPr>
+          <p:cNvPr id="27" name="Text 25"/>
+          <p:cNvSpPr/>
+          <p:nvPr/>
+        </p:nvSpPr>
+        <p:spPr>
+          <a:xfrm>
+            <a:off x="2743200" y="2002536"/>
+            <a:ext cx="7452360" cy="310896"/>
+          </a:xfrm>
+          <a:prstGeom prst="rect">
+            <a:avLst/>
+          </a:prstGeom>
+          <a:noFill/>
+          <a:ln/>
+        </p:spPr>
+        <p:txBody>
+          <a:bodyPr wrap="square" lIns="635" tIns="635" rIns="635" bIns="635" rtlCol="0" anchor="ctr">
+            <a:normAutofit/>
+          </a:bodyPr>
+          <a:lstStyle/>
+          <a:p>
+            <a:pPr algn="l" indent="0" marL="0">
+              <a:buNone/>
+            </a:pPr>
+            <a:r>
+              <a:rPr lang="en-US" sz="1300" dirty="0">
+                <a:solidFill>
+                  <a:srgbClr val="163044"/>
+                </a:solidFill>
+                <a:latin typeface="Microsoft JhengHei" pitchFamily="34" charset="0"/>
+                <a:ea typeface="Microsoft JhengHei" pitchFamily="34" charset="-122"/>
+                <a:cs typeface="Microsoft JhengHei" pitchFamily="34" charset="-120"/>
+              </a:rPr>
+              <a:t>比……多多少</a:t>
+            </a:r>
             <a:endParaRPr lang="en-US" sz="1300" dirty="0"/>
           </a:p>
         </p:txBody>
       </p:sp>
       <p:sp>
         <p:nvSpPr>
-          <p:cNvPr id="27" name="Text 25"/>
-          <p:cNvSpPr/>
-          <p:nvPr/>
-        </p:nvSpPr>
-        <p:spPr>
-          <a:xfrm>
-            <a:off x="2743200" y="2295144"/>
-            <a:ext cx="7452360" cy="420624"/>
+          <p:cNvPr id="28" name="Shape 26"/>
+          <p:cNvSpPr/>
+          <p:nvPr/>
+        </p:nvSpPr>
+        <p:spPr>
+          <a:xfrm>
+            <a:off x="1325880" y="2304288"/>
+            <a:ext cx="1234440" cy="310896"/>
+          </a:xfrm>
+          <a:prstGeom prst="roundRect">
+            <a:avLst/>
+          </a:prstGeom>
+          <a:solidFill>
+            <a:srgbClr val="F3E8FF"/>
+          </a:solidFill>
+          <a:ln w="21590">
+            <a:solidFill>
+              <a:srgbClr val="7C3AED"/>
+            </a:solidFill>
+            <a:prstDash val="solid"/>
+          </a:ln>
+        </p:spPr>
+      </p:sp>
+      <p:sp>
+        <p:nvSpPr>
+          <p:cNvPr id="29" name="Text 27"/>
+          <p:cNvSpPr/>
+          <p:nvPr/>
+        </p:nvSpPr>
+        <p:spPr>
+          <a:xfrm>
+            <a:off x="1353312" y="2322576"/>
+            <a:ext cx="1179576" cy="274320"/>
+          </a:xfrm>
+          <a:prstGeom prst="rect">
+            <a:avLst/>
+          </a:prstGeom>
+          <a:noFill/>
+          <a:ln/>
+        </p:spPr>
+        <p:txBody>
+          <a:bodyPr wrap="square" lIns="635" tIns="635" rIns="635" bIns="635" rtlCol="0" anchor="ctr">
+            <a:normAutofit/>
+          </a:bodyPr>
+          <a:lstStyle/>
+          <a:p>
+            <a:pPr algn="ctr" indent="0" marL="0">
+              <a:buNone/>
+            </a:pPr>
+            <a:r>
+              <a:rPr lang="en-US" sz="1100" b="1" dirty="0">
+                <a:solidFill>
+                  <a:srgbClr val="7C3AED"/>
+                </a:solidFill>
+                <a:latin typeface="Microsoft JhengHei" pitchFamily="34" charset="0"/>
+                <a:ea typeface="Microsoft JhengHei" pitchFamily="34" charset="-122"/>
+                <a:cs typeface="Microsoft JhengHei" pitchFamily="34" charset="-120"/>
+              </a:rPr>
+              <a:t>判斷</a:t>
+            </a:r>
+            <a:endParaRPr lang="en-US" sz="1100" dirty="0"/>
+          </a:p>
+        </p:txBody>
+      </p:sp>
+      <p:sp>
+        <p:nvSpPr>
+          <p:cNvPr id="30" name="Text 28"/>
+          <p:cNvSpPr/>
+          <p:nvPr/>
+        </p:nvSpPr>
+        <p:spPr>
+          <a:xfrm>
+            <a:off x="2743200" y="2286000"/>
+            <a:ext cx="7452360" cy="292608"/>
           </a:xfrm>
           <a:prstGeom prst="rect">
             <a:avLst/>
@@ -37484,7 +37591,7 @@
               <a:buNone/>
             </a:pPr>
             <a:r>
-              <a:rPr lang="en-US" sz="1600" dirty="0">
+              <a:rPr lang="en-US" sz="1250" dirty="0">
                 <a:solidFill>
                   <a:srgbClr val="163044"/>
                 </a:solidFill>
@@ -37492,7 +37599,221 @@
                 <a:ea typeface="Microsoft JhengHei" pitchFamily="34" charset="-122"/>
                 <a:cs typeface="Microsoft JhengHei" pitchFamily="34" charset="-120"/>
               </a:rPr>
-              <a:t>比……多多少</a:t>
+              <a:t>比較差距，用減法。</a:t>
+            </a:r>
+            <a:endParaRPr lang="en-US" sz="1250" dirty="0"/>
+          </a:p>
+        </p:txBody>
+      </p:sp>
+      <p:sp>
+        <p:nvSpPr>
+          <p:cNvPr id="31" name="Shape 29"/>
+          <p:cNvSpPr/>
+          <p:nvPr/>
+        </p:nvSpPr>
+        <p:spPr>
+          <a:xfrm>
+            <a:off x="1325880" y="2578608"/>
+            <a:ext cx="1234440" cy="310896"/>
+          </a:xfrm>
+          <a:prstGeom prst="roundRect">
+            <a:avLst/>
+          </a:prstGeom>
+          <a:solidFill>
+            <a:srgbClr val="F3E8FF"/>
+          </a:solidFill>
+          <a:ln w="21590">
+            <a:solidFill>
+              <a:srgbClr val="7C3AED"/>
+            </a:solidFill>
+            <a:prstDash val="solid"/>
+          </a:ln>
+        </p:spPr>
+      </p:sp>
+      <p:sp>
+        <p:nvSpPr>
+          <p:cNvPr id="32" name="Text 30"/>
+          <p:cNvSpPr/>
+          <p:nvPr/>
+        </p:nvSpPr>
+        <p:spPr>
+          <a:xfrm>
+            <a:off x="1353312" y="2596896"/>
+            <a:ext cx="1179576" cy="274320"/>
+          </a:xfrm>
+          <a:prstGeom prst="rect">
+            <a:avLst/>
+          </a:prstGeom>
+          <a:noFill/>
+          <a:ln/>
+        </p:spPr>
+        <p:txBody>
+          <a:bodyPr wrap="square" lIns="635" tIns="635" rIns="635" bIns="635" rtlCol="0" anchor="ctr">
+            <a:normAutofit/>
+          </a:bodyPr>
+          <a:lstStyle/>
+          <a:p>
+            <a:pPr algn="ctr" indent="0" marL="0">
+              <a:buNone/>
+            </a:pPr>
+            <a:r>
+              <a:rPr lang="en-US" sz="1100" b="1" dirty="0">
+                <a:solidFill>
+                  <a:srgbClr val="7C3AED"/>
+                </a:solidFill>
+                <a:latin typeface="Microsoft JhengHei" pitchFamily="34" charset="0"/>
+                <a:ea typeface="Microsoft JhengHei" pitchFamily="34" charset="-122"/>
+                <a:cs typeface="Microsoft JhengHei" pitchFamily="34" charset="-120"/>
+              </a:rPr>
+              <a:t>算式</a:t>
+            </a:r>
+            <a:endParaRPr lang="en-US" sz="1100" dirty="0"/>
+          </a:p>
+        </p:txBody>
+      </p:sp>
+      <p:sp>
+        <p:nvSpPr>
+          <p:cNvPr id="33" name="Text 31"/>
+          <p:cNvSpPr/>
+          <p:nvPr/>
+        </p:nvSpPr>
+        <p:spPr>
+          <a:xfrm>
+            <a:off x="2743200" y="2560320"/>
+            <a:ext cx="7452360" cy="292608"/>
+          </a:xfrm>
+          <a:prstGeom prst="rect">
+            <a:avLst/>
+          </a:prstGeom>
+          <a:noFill/>
+          <a:ln/>
+        </p:spPr>
+        <p:txBody>
+          <a:bodyPr wrap="square" lIns="635" tIns="635" rIns="635" bIns="635" rtlCol="0" anchor="ctr">
+            <a:normAutofit/>
+          </a:bodyPr>
+          <a:lstStyle/>
+          <a:p>
+            <a:pPr algn="l" indent="0" marL="0">
+              <a:buNone/>
+            </a:pPr>
+            <a:r>
+              <a:rPr lang="en-US" sz="1550" b="1" dirty="0">
+                <a:solidFill>
+                  <a:srgbClr val="7C3AED"/>
+                </a:solidFill>
+                <a:latin typeface="Microsoft JhengHei" pitchFamily="34" charset="0"/>
+                <a:ea typeface="Microsoft JhengHei" pitchFamily="34" charset="-122"/>
+                <a:cs typeface="Microsoft JhengHei" pitchFamily="34" charset="-120"/>
+              </a:rPr>
+              <a:t>40 － 25 ＝ 15</a:t>
+            </a:r>
+            <a:endParaRPr lang="en-US" sz="1550" dirty="0"/>
+          </a:p>
+        </p:txBody>
+      </p:sp>
+      <p:sp>
+        <p:nvSpPr>
+          <p:cNvPr id="34" name="Shape 32"/>
+          <p:cNvSpPr/>
+          <p:nvPr/>
+        </p:nvSpPr>
+        <p:spPr>
+          <a:xfrm>
+            <a:off x="713232" y="3108960"/>
+            <a:ext cx="10332720" cy="1261872"/>
+          </a:xfrm>
+          <a:prstGeom prst="roundRect">
+            <a:avLst/>
+          </a:prstGeom>
+          <a:solidFill>
+            <a:srgbClr val="FFFFFF"/>
+          </a:solidFill>
+          <a:ln w="25400">
+            <a:solidFill>
+              <a:srgbClr val="DDD6FE"/>
+            </a:solidFill>
+            <a:prstDash val="solid"/>
+          </a:ln>
+        </p:spPr>
+      </p:sp>
+      <p:sp>
+        <p:nvSpPr>
+          <p:cNvPr id="35" name="Text 33"/>
+          <p:cNvSpPr/>
+          <p:nvPr/>
+        </p:nvSpPr>
+        <p:spPr>
+          <a:xfrm>
+            <a:off x="896112" y="3236976"/>
+            <a:ext cx="314919" cy="314919"/>
+          </a:xfrm>
+          <a:prstGeom prst="rect">
+            <a:avLst/>
+          </a:prstGeom>
+          <a:noFill/>
+          <a:ln/>
+        </p:spPr>
+        <p:txBody>
+          <a:bodyPr wrap="square" lIns="635" tIns="635" rIns="635" bIns="635" rtlCol="0" anchor="ctr">
+            <a:normAutofit/>
+          </a:bodyPr>
+          <a:lstStyle/>
+          <a:p>
+            <a:pPr algn="ctr" indent="0" marL="0">
+              <a:buNone/>
+            </a:pPr>
+            <a:r>
+              <a:rPr lang="en-US" sz="2132" b="1" dirty="0">
+                <a:solidFill>
+                  <a:srgbClr val="166534"/>
+                </a:solidFill>
+                <a:latin typeface="Microsoft JhengHei" pitchFamily="34" charset="0"/>
+                <a:ea typeface="Microsoft JhengHei" pitchFamily="34" charset="-122"/>
+                <a:cs typeface="Microsoft JhengHei" pitchFamily="34" charset="-120"/>
+              </a:rPr>
+              <a:t>✓</a:t>
+            </a:r>
+            <a:endParaRPr lang="en-US" sz="2132" dirty="0"/>
+          </a:p>
+        </p:txBody>
+      </p:sp>
+      <p:sp>
+        <p:nvSpPr>
+          <p:cNvPr id="36" name="Text 34"/>
+          <p:cNvSpPr/>
+          <p:nvPr/>
+        </p:nvSpPr>
+        <p:spPr>
+          <a:xfrm>
+            <a:off x="1325880" y="3246120"/>
+            <a:ext cx="1005840" cy="292608"/>
+          </a:xfrm>
+          <a:prstGeom prst="rect">
+            <a:avLst/>
+          </a:prstGeom>
+          <a:noFill/>
+          <a:ln/>
+        </p:spPr>
+        <p:txBody>
+          <a:bodyPr wrap="square" lIns="635" tIns="635" rIns="635" bIns="635" rtlCol="0" anchor="ctr">
+            <a:normAutofit/>
+          </a:bodyPr>
+          <a:lstStyle/>
+          <a:p>
+            <a:pPr algn="l" indent="0" marL="0">
+              <a:buNone/>
+            </a:pPr>
+            <a:r>
+              <a:rPr lang="en-US" sz="1600" b="1" dirty="0">
+                <a:solidFill>
+                  <a:srgbClr val="7C3AED"/>
+                </a:solidFill>
+                <a:latin typeface="Microsoft JhengHei" pitchFamily="34" charset="0"/>
+                <a:ea typeface="Microsoft JhengHei" pitchFamily="34" charset="-122"/>
+                <a:cs typeface="Microsoft JhengHei" pitchFamily="34" charset="-120"/>
+              </a:rPr>
+              <a:t>題目 B</a:t>
             </a:r>
             <a:endParaRPr lang="en-US" sz="1600" dirty="0"/>
           </a:p>
@@ -37500,13 +37821,13 @@
       </p:sp>
       <p:sp>
         <p:nvSpPr>
-          <p:cNvPr id="28" name="Shape 26"/>
-          <p:cNvSpPr/>
-          <p:nvPr/>
-        </p:nvSpPr>
-        <p:spPr>
-          <a:xfrm>
-            <a:off x="1325880" y="2715768"/>
+          <p:cNvPr id="37" name="Shape 35"/>
+          <p:cNvSpPr/>
+          <p:nvPr/>
+        </p:nvSpPr>
+        <p:spPr>
+          <a:xfrm>
+            <a:off x="1325880" y="3557016"/>
             <a:ext cx="1234440" cy="310896"/>
           </a:xfrm>
           <a:prstGeom prst="roundRect">
@@ -37525,13 +37846,13 @@
       </p:sp>
       <p:sp>
         <p:nvSpPr>
-          <p:cNvPr id="29" name="Text 27"/>
-          <p:cNvSpPr/>
-          <p:nvPr/>
-        </p:nvSpPr>
-        <p:spPr>
-          <a:xfrm>
-            <a:off x="1353312" y="2734056"/>
+          <p:cNvPr id="38" name="Text 36"/>
+          <p:cNvSpPr/>
+          <p:nvPr/>
+        </p:nvSpPr>
+        <p:spPr>
+          <a:xfrm>
+            <a:off x="1353312" y="3575304"/>
             <a:ext cx="1179576" cy="274320"/>
           </a:xfrm>
           <a:prstGeom prst="rect">
@@ -37550,7 +37871,7 @@
               <a:buNone/>
             </a:pPr>
             <a:r>
-              <a:rPr lang="en-US" sz="1300" b="1" dirty="0">
+              <a:rPr lang="en-US" sz="1100" b="1" dirty="0">
                 <a:solidFill>
                   <a:srgbClr val="7C3AED"/>
                 </a:solidFill>
@@ -37558,22 +37879,557 @@
                 <a:ea typeface="Microsoft JhengHei" pitchFamily="34" charset="-122"/>
                 <a:cs typeface="Microsoft JhengHei" pitchFamily="34" charset="-120"/>
               </a:rPr>
+              <a:t>重點字</a:t>
+            </a:r>
+            <a:endParaRPr lang="en-US" sz="1100" dirty="0"/>
+          </a:p>
+        </p:txBody>
+      </p:sp>
+      <p:sp>
+        <p:nvSpPr>
+          <p:cNvPr id="39" name="Text 37"/>
+          <p:cNvSpPr/>
+          <p:nvPr/>
+        </p:nvSpPr>
+        <p:spPr>
+          <a:xfrm>
+            <a:off x="2743200" y="3538728"/>
+            <a:ext cx="7452360" cy="310896"/>
+          </a:xfrm>
+          <a:prstGeom prst="rect">
+            <a:avLst/>
+          </a:prstGeom>
+          <a:noFill/>
+          <a:ln/>
+        </p:spPr>
+        <p:txBody>
+          <a:bodyPr wrap="square" lIns="635" tIns="635" rIns="635" bIns="635" rtlCol="0" anchor="ctr">
+            <a:normAutofit/>
+          </a:bodyPr>
+          <a:lstStyle/>
+          <a:p>
+            <a:pPr algn="l" indent="0" marL="0">
+              <a:buNone/>
+            </a:pPr>
+            <a:r>
+              <a:rPr lang="en-US" sz="1300" dirty="0">
+                <a:solidFill>
+                  <a:srgbClr val="163044"/>
+                </a:solidFill>
+                <a:latin typeface="Microsoft JhengHei" pitchFamily="34" charset="0"/>
+                <a:ea typeface="Microsoft JhengHei" pitchFamily="34" charset="-122"/>
+                <a:cs typeface="Microsoft JhengHei" pitchFamily="34" charset="-120"/>
+              </a:rPr>
+              <a:t>每人、有 20 人</a:t>
+            </a:r>
+            <a:endParaRPr lang="en-US" sz="1300" dirty="0"/>
+          </a:p>
+        </p:txBody>
+      </p:sp>
+      <p:sp>
+        <p:nvSpPr>
+          <p:cNvPr id="40" name="Shape 38"/>
+          <p:cNvSpPr/>
+          <p:nvPr/>
+        </p:nvSpPr>
+        <p:spPr>
+          <a:xfrm>
+            <a:off x="1325880" y="3840480"/>
+            <a:ext cx="1234440" cy="310896"/>
+          </a:xfrm>
+          <a:prstGeom prst="roundRect">
+            <a:avLst/>
+          </a:prstGeom>
+          <a:solidFill>
+            <a:srgbClr val="F3E8FF"/>
+          </a:solidFill>
+          <a:ln w="21590">
+            <a:solidFill>
+              <a:srgbClr val="7C3AED"/>
+            </a:solidFill>
+            <a:prstDash val="solid"/>
+          </a:ln>
+        </p:spPr>
+      </p:sp>
+      <p:sp>
+        <p:nvSpPr>
+          <p:cNvPr id="41" name="Text 39"/>
+          <p:cNvSpPr/>
+          <p:nvPr/>
+        </p:nvSpPr>
+        <p:spPr>
+          <a:xfrm>
+            <a:off x="1353312" y="3858768"/>
+            <a:ext cx="1179576" cy="274320"/>
+          </a:xfrm>
+          <a:prstGeom prst="rect">
+            <a:avLst/>
+          </a:prstGeom>
+          <a:noFill/>
+          <a:ln/>
+        </p:spPr>
+        <p:txBody>
+          <a:bodyPr wrap="square" lIns="635" tIns="635" rIns="635" bIns="635" rtlCol="0" anchor="ctr">
+            <a:normAutofit/>
+          </a:bodyPr>
+          <a:lstStyle/>
+          <a:p>
+            <a:pPr algn="ctr" indent="0" marL="0">
+              <a:buNone/>
+            </a:pPr>
+            <a:r>
+              <a:rPr lang="en-US" sz="1100" b="1" dirty="0">
+                <a:solidFill>
+                  <a:srgbClr val="7C3AED"/>
+                </a:solidFill>
+                <a:latin typeface="Microsoft JhengHei" pitchFamily="34" charset="0"/>
+                <a:ea typeface="Microsoft JhengHei" pitchFamily="34" charset="-122"/>
+                <a:cs typeface="Microsoft JhengHei" pitchFamily="34" charset="-120"/>
+              </a:rPr>
               <a:t>判斷</a:t>
             </a:r>
+            <a:endParaRPr lang="en-US" sz="1100" dirty="0"/>
+          </a:p>
+        </p:txBody>
+      </p:sp>
+      <p:sp>
+        <p:nvSpPr>
+          <p:cNvPr id="42" name="Text 40"/>
+          <p:cNvSpPr/>
+          <p:nvPr/>
+        </p:nvSpPr>
+        <p:spPr>
+          <a:xfrm>
+            <a:off x="2743200" y="3822192"/>
+            <a:ext cx="7452360" cy="292608"/>
+          </a:xfrm>
+          <a:prstGeom prst="rect">
+            <a:avLst/>
+          </a:prstGeom>
+          <a:noFill/>
+          <a:ln/>
+        </p:spPr>
+        <p:txBody>
+          <a:bodyPr wrap="square" lIns="635" tIns="635" rIns="635" bIns="635" rtlCol="0" anchor="ctr">
+            <a:normAutofit/>
+          </a:bodyPr>
+          <a:lstStyle/>
+          <a:p>
+            <a:pPr algn="l" indent="0" marL="0">
+              <a:buNone/>
+            </a:pPr>
+            <a:r>
+              <a:rPr lang="en-US" sz="1250" dirty="0">
+                <a:solidFill>
+                  <a:srgbClr val="163044"/>
+                </a:solidFill>
+                <a:latin typeface="Microsoft JhengHei" pitchFamily="34" charset="0"/>
+                <a:ea typeface="Microsoft JhengHei" pitchFamily="34" charset="-122"/>
+                <a:cs typeface="Microsoft JhengHei" pitchFamily="34" charset="-120"/>
+              </a:rPr>
+              <a:t>每人一樣多，用乘法。</a:t>
+            </a:r>
+            <a:endParaRPr lang="en-US" sz="1250" dirty="0"/>
+          </a:p>
+        </p:txBody>
+      </p:sp>
+      <p:sp>
+        <p:nvSpPr>
+          <p:cNvPr id="43" name="Shape 41"/>
+          <p:cNvSpPr/>
+          <p:nvPr/>
+        </p:nvSpPr>
+        <p:spPr>
+          <a:xfrm>
+            <a:off x="1325880" y="4114800"/>
+            <a:ext cx="1234440" cy="310896"/>
+          </a:xfrm>
+          <a:prstGeom prst="roundRect">
+            <a:avLst/>
+          </a:prstGeom>
+          <a:solidFill>
+            <a:srgbClr val="F3E8FF"/>
+          </a:solidFill>
+          <a:ln w="21590">
+            <a:solidFill>
+              <a:srgbClr val="7C3AED"/>
+            </a:solidFill>
+            <a:prstDash val="solid"/>
+          </a:ln>
+        </p:spPr>
+      </p:sp>
+      <p:sp>
+        <p:nvSpPr>
+          <p:cNvPr id="44" name="Text 42"/>
+          <p:cNvSpPr/>
+          <p:nvPr/>
+        </p:nvSpPr>
+        <p:spPr>
+          <a:xfrm>
+            <a:off x="1353312" y="4133088"/>
+            <a:ext cx="1179576" cy="274320"/>
+          </a:xfrm>
+          <a:prstGeom prst="rect">
+            <a:avLst/>
+          </a:prstGeom>
+          <a:noFill/>
+          <a:ln/>
+        </p:spPr>
+        <p:txBody>
+          <a:bodyPr wrap="square" lIns="635" tIns="635" rIns="635" bIns="635" rtlCol="0" anchor="ctr">
+            <a:normAutofit/>
+          </a:bodyPr>
+          <a:lstStyle/>
+          <a:p>
+            <a:pPr algn="ctr" indent="0" marL="0">
+              <a:buNone/>
+            </a:pPr>
+            <a:r>
+              <a:rPr lang="en-US" sz="1100" b="1" dirty="0">
+                <a:solidFill>
+                  <a:srgbClr val="7C3AED"/>
+                </a:solidFill>
+                <a:latin typeface="Microsoft JhengHei" pitchFamily="34" charset="0"/>
+                <a:ea typeface="Microsoft JhengHei" pitchFamily="34" charset="-122"/>
+                <a:cs typeface="Microsoft JhengHei" pitchFamily="34" charset="-120"/>
+              </a:rPr>
+              <a:t>算式</a:t>
+            </a:r>
+            <a:endParaRPr lang="en-US" sz="1100" dirty="0"/>
+          </a:p>
+        </p:txBody>
+      </p:sp>
+      <p:sp>
+        <p:nvSpPr>
+          <p:cNvPr id="45" name="Text 43"/>
+          <p:cNvSpPr/>
+          <p:nvPr/>
+        </p:nvSpPr>
+        <p:spPr>
+          <a:xfrm>
+            <a:off x="2743200" y="4096512"/>
+            <a:ext cx="7452360" cy="292608"/>
+          </a:xfrm>
+          <a:prstGeom prst="rect">
+            <a:avLst/>
+          </a:prstGeom>
+          <a:noFill/>
+          <a:ln/>
+        </p:spPr>
+        <p:txBody>
+          <a:bodyPr wrap="square" lIns="635" tIns="635" rIns="635" bIns="635" rtlCol="0" anchor="ctr">
+            <a:normAutofit/>
+          </a:bodyPr>
+          <a:lstStyle/>
+          <a:p>
+            <a:pPr algn="l" indent="0" marL="0">
+              <a:buNone/>
+            </a:pPr>
+            <a:r>
+              <a:rPr lang="en-US" sz="1550" b="1" dirty="0">
+                <a:solidFill>
+                  <a:srgbClr val="7C3AED"/>
+                </a:solidFill>
+                <a:latin typeface="Microsoft JhengHei" pitchFamily="34" charset="0"/>
+                <a:ea typeface="Microsoft JhengHei" pitchFamily="34" charset="-122"/>
+                <a:cs typeface="Microsoft JhengHei" pitchFamily="34" charset="-120"/>
+              </a:rPr>
+              <a:t>3 × 20 ＝ 60</a:t>
+            </a:r>
+            <a:endParaRPr lang="en-US" sz="1550" dirty="0"/>
+          </a:p>
+        </p:txBody>
+      </p:sp>
+      <p:sp>
+        <p:nvSpPr>
+          <p:cNvPr id="46" name="Shape 44"/>
+          <p:cNvSpPr/>
+          <p:nvPr/>
+        </p:nvSpPr>
+        <p:spPr>
+          <a:xfrm>
+            <a:off x="713232" y="4645152"/>
+            <a:ext cx="10332720" cy="1261872"/>
+          </a:xfrm>
+          <a:prstGeom prst="roundRect">
+            <a:avLst/>
+          </a:prstGeom>
+          <a:solidFill>
+            <a:srgbClr val="FFFFFF"/>
+          </a:solidFill>
+          <a:ln w="25400">
+            <a:solidFill>
+              <a:srgbClr val="DDD6FE"/>
+            </a:solidFill>
+            <a:prstDash val="solid"/>
+          </a:ln>
+        </p:spPr>
+      </p:sp>
+      <p:sp>
+        <p:nvSpPr>
+          <p:cNvPr id="47" name="Text 45"/>
+          <p:cNvSpPr/>
+          <p:nvPr/>
+        </p:nvSpPr>
+        <p:spPr>
+          <a:xfrm>
+            <a:off x="896112" y="4773168"/>
+            <a:ext cx="314919" cy="314919"/>
+          </a:xfrm>
+          <a:prstGeom prst="rect">
+            <a:avLst/>
+          </a:prstGeom>
+          <a:noFill/>
+          <a:ln/>
+        </p:spPr>
+        <p:txBody>
+          <a:bodyPr wrap="square" lIns="635" tIns="635" rIns="635" bIns="635" rtlCol="0" anchor="ctr">
+            <a:normAutofit/>
+          </a:bodyPr>
+          <a:lstStyle/>
+          <a:p>
+            <a:pPr algn="ctr" indent="0" marL="0">
+              <a:buNone/>
+            </a:pPr>
+            <a:r>
+              <a:rPr lang="en-US" sz="2132" b="1" dirty="0">
+                <a:solidFill>
+                  <a:srgbClr val="166534"/>
+                </a:solidFill>
+                <a:latin typeface="Microsoft JhengHei" pitchFamily="34" charset="0"/>
+                <a:ea typeface="Microsoft JhengHei" pitchFamily="34" charset="-122"/>
+                <a:cs typeface="Microsoft JhengHei" pitchFamily="34" charset="-120"/>
+              </a:rPr>
+              <a:t>✓</a:t>
+            </a:r>
+            <a:endParaRPr lang="en-US" sz="2132" dirty="0"/>
+          </a:p>
+        </p:txBody>
+      </p:sp>
+      <p:sp>
+        <p:nvSpPr>
+          <p:cNvPr id="48" name="Text 46"/>
+          <p:cNvSpPr/>
+          <p:nvPr/>
+        </p:nvSpPr>
+        <p:spPr>
+          <a:xfrm>
+            <a:off x="1325880" y="4782312"/>
+            <a:ext cx="1005840" cy="292608"/>
+          </a:xfrm>
+          <a:prstGeom prst="rect">
+            <a:avLst/>
+          </a:prstGeom>
+          <a:noFill/>
+          <a:ln/>
+        </p:spPr>
+        <p:txBody>
+          <a:bodyPr wrap="square" lIns="635" tIns="635" rIns="635" bIns="635" rtlCol="0" anchor="ctr">
+            <a:normAutofit/>
+          </a:bodyPr>
+          <a:lstStyle/>
+          <a:p>
+            <a:pPr algn="l" indent="0" marL="0">
+              <a:buNone/>
+            </a:pPr>
+            <a:r>
+              <a:rPr lang="en-US" sz="1600" b="1" dirty="0">
+                <a:solidFill>
+                  <a:srgbClr val="7C3AED"/>
+                </a:solidFill>
+                <a:latin typeface="Microsoft JhengHei" pitchFamily="34" charset="0"/>
+                <a:ea typeface="Microsoft JhengHei" pitchFamily="34" charset="-122"/>
+                <a:cs typeface="Microsoft JhengHei" pitchFamily="34" charset="-120"/>
+              </a:rPr>
+              <a:t>題目 C</a:t>
+            </a:r>
+            <a:endParaRPr lang="en-US" sz="1600" dirty="0"/>
+          </a:p>
+        </p:txBody>
+      </p:sp>
+      <p:sp>
+        <p:nvSpPr>
+          <p:cNvPr id="49" name="Shape 47"/>
+          <p:cNvSpPr/>
+          <p:nvPr/>
+        </p:nvSpPr>
+        <p:spPr>
+          <a:xfrm>
+            <a:off x="1325880" y="5093208"/>
+            <a:ext cx="1234440" cy="310896"/>
+          </a:xfrm>
+          <a:prstGeom prst="roundRect">
+            <a:avLst/>
+          </a:prstGeom>
+          <a:solidFill>
+            <a:srgbClr val="F3E8FF"/>
+          </a:solidFill>
+          <a:ln w="21590">
+            <a:solidFill>
+              <a:srgbClr val="7C3AED"/>
+            </a:solidFill>
+            <a:prstDash val="solid"/>
+          </a:ln>
+        </p:spPr>
+      </p:sp>
+      <p:sp>
+        <p:nvSpPr>
+          <p:cNvPr id="50" name="Text 48"/>
+          <p:cNvSpPr/>
+          <p:nvPr/>
+        </p:nvSpPr>
+        <p:spPr>
+          <a:xfrm>
+            <a:off x="1353312" y="5111496"/>
+            <a:ext cx="1179576" cy="274320"/>
+          </a:xfrm>
+          <a:prstGeom prst="rect">
+            <a:avLst/>
+          </a:prstGeom>
+          <a:noFill/>
+          <a:ln/>
+        </p:spPr>
+        <p:txBody>
+          <a:bodyPr wrap="square" lIns="635" tIns="635" rIns="635" bIns="635" rtlCol="0" anchor="ctr">
+            <a:normAutofit/>
+          </a:bodyPr>
+          <a:lstStyle/>
+          <a:p>
+            <a:pPr algn="ctr" indent="0" marL="0">
+              <a:buNone/>
+            </a:pPr>
+            <a:r>
+              <a:rPr lang="en-US" sz="1100" b="1" dirty="0">
+                <a:solidFill>
+                  <a:srgbClr val="7C3AED"/>
+                </a:solidFill>
+                <a:latin typeface="Microsoft JhengHei" pitchFamily="34" charset="0"/>
+                <a:ea typeface="Microsoft JhengHei" pitchFamily="34" charset="-122"/>
+                <a:cs typeface="Microsoft JhengHei" pitchFamily="34" charset="-120"/>
+              </a:rPr>
+              <a:t>重點字</a:t>
+            </a:r>
+            <a:endParaRPr lang="en-US" sz="1100" dirty="0"/>
+          </a:p>
+        </p:txBody>
+      </p:sp>
+      <p:sp>
+        <p:nvSpPr>
+          <p:cNvPr id="51" name="Text 49"/>
+          <p:cNvSpPr/>
+          <p:nvPr/>
+        </p:nvSpPr>
+        <p:spPr>
+          <a:xfrm>
+            <a:off x="2743200" y="5074920"/>
+            <a:ext cx="7452360" cy="310896"/>
+          </a:xfrm>
+          <a:prstGeom prst="rect">
+            <a:avLst/>
+          </a:prstGeom>
+          <a:noFill/>
+          <a:ln/>
+        </p:spPr>
+        <p:txBody>
+          <a:bodyPr wrap="square" lIns="635" tIns="635" rIns="635" bIns="635" rtlCol="0" anchor="ctr">
+            <a:normAutofit/>
+          </a:bodyPr>
+          <a:lstStyle/>
+          <a:p>
+            <a:pPr algn="l" indent="0" marL="0">
+              <a:buNone/>
+            </a:pPr>
+            <a:r>
+              <a:rPr lang="en-US" sz="1300" dirty="0">
+                <a:solidFill>
+                  <a:srgbClr val="163044"/>
+                </a:solidFill>
+                <a:latin typeface="Microsoft JhengHei" pitchFamily="34" charset="0"/>
+                <a:ea typeface="Microsoft JhengHei" pitchFamily="34" charset="-122"/>
+                <a:cs typeface="Microsoft JhengHei" pitchFamily="34" charset="-120"/>
+              </a:rPr>
+              <a:t>紅花和黃花合起來</a:t>
+            </a:r>
             <a:endParaRPr lang="en-US" sz="1300" dirty="0"/>
           </a:p>
         </p:txBody>
       </p:sp>
       <p:sp>
         <p:nvSpPr>
-          <p:cNvPr id="30" name="Text 28"/>
-          <p:cNvSpPr/>
-          <p:nvPr/>
-        </p:nvSpPr>
-        <p:spPr>
-          <a:xfrm>
-            <a:off x="2743200" y="2697480"/>
-            <a:ext cx="7452360" cy="420624"/>
+          <p:cNvPr id="52" name="Shape 50"/>
+          <p:cNvSpPr/>
+          <p:nvPr/>
+        </p:nvSpPr>
+        <p:spPr>
+          <a:xfrm>
+            <a:off x="1325880" y="5376672"/>
+            <a:ext cx="1234440" cy="310896"/>
+          </a:xfrm>
+          <a:prstGeom prst="roundRect">
+            <a:avLst/>
+          </a:prstGeom>
+          <a:solidFill>
+            <a:srgbClr val="F3E8FF"/>
+          </a:solidFill>
+          <a:ln w="21590">
+            <a:solidFill>
+              <a:srgbClr val="7C3AED"/>
+            </a:solidFill>
+            <a:prstDash val="solid"/>
+          </a:ln>
+        </p:spPr>
+      </p:sp>
+      <p:sp>
+        <p:nvSpPr>
+          <p:cNvPr id="53" name="Text 51"/>
+          <p:cNvSpPr/>
+          <p:nvPr/>
+        </p:nvSpPr>
+        <p:spPr>
+          <a:xfrm>
+            <a:off x="1353312" y="5394960"/>
+            <a:ext cx="1179576" cy="274320"/>
+          </a:xfrm>
+          <a:prstGeom prst="rect">
+            <a:avLst/>
+          </a:prstGeom>
+          <a:noFill/>
+          <a:ln/>
+        </p:spPr>
+        <p:txBody>
+          <a:bodyPr wrap="square" lIns="635" tIns="635" rIns="635" bIns="635" rtlCol="0" anchor="ctr">
+            <a:normAutofit/>
+          </a:bodyPr>
+          <a:lstStyle/>
+          <a:p>
+            <a:pPr algn="ctr" indent="0" marL="0">
+              <a:buNone/>
+            </a:pPr>
+            <a:r>
+              <a:rPr lang="en-US" sz="1100" b="1" dirty="0">
+                <a:solidFill>
+                  <a:srgbClr val="7C3AED"/>
+                </a:solidFill>
+                <a:latin typeface="Microsoft JhengHei" pitchFamily="34" charset="0"/>
+                <a:ea typeface="Microsoft JhengHei" pitchFamily="34" charset="-122"/>
+                <a:cs typeface="Microsoft JhengHei" pitchFamily="34" charset="-120"/>
+              </a:rPr>
+              <a:t>判斷</a:t>
+            </a:r>
+            <a:endParaRPr lang="en-US" sz="1100" dirty="0"/>
+          </a:p>
+        </p:txBody>
+      </p:sp>
+      <p:sp>
+        <p:nvSpPr>
+          <p:cNvPr id="54" name="Text 52"/>
+          <p:cNvSpPr/>
+          <p:nvPr/>
+        </p:nvSpPr>
+        <p:spPr>
+          <a:xfrm>
+            <a:off x="2743200" y="5358384"/>
+            <a:ext cx="7452360" cy="292608"/>
           </a:xfrm>
           <a:prstGeom prst="rect">
             <a:avLst/>
@@ -37591,7 +38447,7 @@
               <a:buNone/>
             </a:pPr>
             <a:r>
-              <a:rPr lang="en-US" sz="1500" dirty="0">
+              <a:rPr lang="en-US" sz="1250" dirty="0">
                 <a:solidFill>
                   <a:srgbClr val="163044"/>
                 </a:solidFill>
@@ -37599,21 +38455,21 @@
                 <a:ea typeface="Microsoft JhengHei" pitchFamily="34" charset="-122"/>
                 <a:cs typeface="Microsoft JhengHei" pitchFamily="34" charset="-120"/>
               </a:rPr>
-              <a:t>比較差距，用減法。</a:t>
-            </a:r>
-            <a:endParaRPr lang="en-US" sz="1500" dirty="0"/>
-          </a:p>
-        </p:txBody>
-      </p:sp>
-      <p:sp>
-        <p:nvSpPr>
-          <p:cNvPr id="31" name="Shape 29"/>
-          <p:cNvSpPr/>
-          <p:nvPr/>
-        </p:nvSpPr>
-        <p:spPr>
-          <a:xfrm>
-            <a:off x="1325880" y="3108960"/>
+              <a:t>兩種花合共，用加法。</a:t>
+            </a:r>
+            <a:endParaRPr lang="en-US" sz="1250" dirty="0"/>
+          </a:p>
+        </p:txBody>
+      </p:sp>
+      <p:sp>
+        <p:nvSpPr>
+          <p:cNvPr id="55" name="Shape 53"/>
+          <p:cNvSpPr/>
+          <p:nvPr/>
+        </p:nvSpPr>
+        <p:spPr>
+          <a:xfrm>
+            <a:off x="1325880" y="5650992"/>
             <a:ext cx="1234440" cy="310896"/>
           </a:xfrm>
           <a:prstGeom prst="roundRect">
@@ -37632,13 +38488,13 @@
       </p:sp>
       <p:sp>
         <p:nvSpPr>
-          <p:cNvPr id="32" name="Text 30"/>
-          <p:cNvSpPr/>
-          <p:nvPr/>
-        </p:nvSpPr>
-        <p:spPr>
-          <a:xfrm>
-            <a:off x="1353312" y="3127248"/>
+          <p:cNvPr id="56" name="Text 54"/>
+          <p:cNvSpPr/>
+          <p:nvPr/>
+        </p:nvSpPr>
+        <p:spPr>
+          <a:xfrm>
+            <a:off x="1353312" y="5669280"/>
             <a:ext cx="1179576" cy="274320"/>
           </a:xfrm>
           <a:prstGeom prst="rect">
@@ -37657,7 +38513,7 @@
               <a:buNone/>
             </a:pPr>
             <a:r>
-              <a:rPr lang="en-US" sz="1300" b="1" dirty="0">
+              <a:rPr lang="en-US" sz="1100" b="1" dirty="0">
                 <a:solidFill>
                   <a:srgbClr val="7C3AED"/>
                 </a:solidFill>
@@ -37667,20 +38523,20 @@
               </a:rPr>
               <a:t>算式</a:t>
             </a:r>
-            <a:endParaRPr lang="en-US" sz="1300" dirty="0"/>
-          </a:p>
-        </p:txBody>
-      </p:sp>
-      <p:sp>
-        <p:nvSpPr>
-          <p:cNvPr id="33" name="Text 31"/>
-          <p:cNvSpPr/>
-          <p:nvPr/>
-        </p:nvSpPr>
-        <p:spPr>
-          <a:xfrm>
-            <a:off x="2743200" y="3090672"/>
-            <a:ext cx="7452360" cy="420624"/>
+            <a:endParaRPr lang="en-US" sz="1100" dirty="0"/>
+          </a:p>
+        </p:txBody>
+      </p:sp>
+      <p:sp>
+        <p:nvSpPr>
+          <p:cNvPr id="57" name="Text 55"/>
+          <p:cNvSpPr/>
+          <p:nvPr/>
+        </p:nvSpPr>
+        <p:spPr>
+          <a:xfrm>
+            <a:off x="2743200" y="5632704"/>
+            <a:ext cx="7452360" cy="292608"/>
           </a:xfrm>
           <a:prstGeom prst="rect">
             <a:avLst/>
@@ -37698,7 +38554,7 @@
               <a:buNone/>
             </a:pPr>
             <a:r>
-              <a:rPr lang="en-US" sz="2000" b="1" dirty="0">
+              <a:rPr lang="en-US" sz="1550" b="1" dirty="0">
                 <a:solidFill>
                   <a:srgbClr val="7C3AED"/>
                 </a:solidFill>
@@ -37706,865 +38562,9 @@
                 <a:ea typeface="Microsoft JhengHei" pitchFamily="34" charset="-122"/>
                 <a:cs typeface="Microsoft JhengHei" pitchFamily="34" charset="-120"/>
               </a:rPr>
-              <a:t>40 － 25 ＝ 15</a:t>
-            </a:r>
-            <a:endParaRPr lang="en-US" sz="2000" dirty="0"/>
-          </a:p>
-        </p:txBody>
-      </p:sp>
-      <p:sp>
-        <p:nvSpPr>
-          <p:cNvPr id="34" name="Shape 32"/>
-          <p:cNvSpPr/>
-          <p:nvPr/>
-        </p:nvSpPr>
-        <p:spPr>
-          <a:xfrm>
-            <a:off x="713232" y="4023360"/>
-            <a:ext cx="10332720" cy="1874520"/>
-          </a:xfrm>
-          <a:prstGeom prst="roundRect">
-            <a:avLst/>
-          </a:prstGeom>
-          <a:solidFill>
-            <a:srgbClr val="FFFFFF"/>
-          </a:solidFill>
-          <a:ln w="25400">
-            <a:solidFill>
-              <a:srgbClr val="DDD6FE"/>
-            </a:solidFill>
-            <a:prstDash val="solid"/>
-          </a:ln>
-        </p:spPr>
-      </p:sp>
-      <p:sp>
-        <p:nvSpPr>
-          <p:cNvPr id="35" name="Text 33"/>
-          <p:cNvSpPr/>
-          <p:nvPr/>
-        </p:nvSpPr>
-        <p:spPr>
-          <a:xfrm>
-            <a:off x="896112" y="4279392"/>
-            <a:ext cx="384048" cy="384048"/>
-          </a:xfrm>
-          <a:prstGeom prst="rect">
-            <a:avLst/>
-          </a:prstGeom>
-          <a:noFill/>
-          <a:ln/>
-        </p:spPr>
-        <p:txBody>
-          <a:bodyPr wrap="square" lIns="635" tIns="635" rIns="635" bIns="635" rtlCol="0" anchor="ctr">
-            <a:normAutofit/>
-          </a:bodyPr>
-          <a:lstStyle/>
-          <a:p>
-            <a:pPr algn="ctr" indent="0" marL="0">
-              <a:buNone/>
-            </a:pPr>
-            <a:r>
-              <a:rPr lang="en-US" sz="2600" b="1" dirty="0">
-                <a:solidFill>
-                  <a:srgbClr val="166534"/>
-                </a:solidFill>
-                <a:latin typeface="Microsoft JhengHei" pitchFamily="34" charset="0"/>
-                <a:ea typeface="Microsoft JhengHei" pitchFamily="34" charset="-122"/>
-                <a:cs typeface="Microsoft JhengHei" pitchFamily="34" charset="-120"/>
-              </a:rPr>
-              <a:t>✓</a:t>
-            </a:r>
-            <a:endParaRPr lang="en-US" sz="2600" dirty="0"/>
-          </a:p>
-        </p:txBody>
-      </p:sp>
-      <p:sp>
-        <p:nvSpPr>
-          <p:cNvPr id="36" name="Text 34"/>
-          <p:cNvSpPr/>
-          <p:nvPr/>
-        </p:nvSpPr>
-        <p:spPr>
-          <a:xfrm>
-            <a:off x="1325880" y="4233672"/>
-            <a:ext cx="1005840" cy="320040"/>
-          </a:xfrm>
-          <a:prstGeom prst="rect">
-            <a:avLst/>
-          </a:prstGeom>
-          <a:noFill/>
-          <a:ln/>
-        </p:spPr>
-        <p:txBody>
-          <a:bodyPr wrap="square" lIns="635" tIns="635" rIns="635" bIns="635" rtlCol="0" anchor="ctr">
-            <a:normAutofit/>
-          </a:bodyPr>
-          <a:lstStyle/>
-          <a:p>
-            <a:pPr algn="l" indent="0" marL="0">
-              <a:buNone/>
-            </a:pPr>
-            <a:r>
-              <a:rPr lang="en-US" sz="1900" b="1" dirty="0">
-                <a:solidFill>
-                  <a:srgbClr val="7C3AED"/>
-                </a:solidFill>
-                <a:latin typeface="Microsoft JhengHei" pitchFamily="34" charset="0"/>
-                <a:ea typeface="Microsoft JhengHei" pitchFamily="34" charset="-122"/>
-                <a:cs typeface="Microsoft JhengHei" pitchFamily="34" charset="-120"/>
-              </a:rPr>
-              <a:t>題目 B</a:t>
-            </a:r>
-            <a:endParaRPr lang="en-US" sz="1900" dirty="0"/>
-          </a:p>
-        </p:txBody>
-      </p:sp>
-      <p:sp>
-        <p:nvSpPr>
-          <p:cNvPr id="37" name="Shape 35"/>
-          <p:cNvSpPr/>
-          <p:nvPr/>
-        </p:nvSpPr>
-        <p:spPr>
-          <a:xfrm>
-            <a:off x="1325880" y="4645152"/>
-            <a:ext cx="1234440" cy="310896"/>
-          </a:xfrm>
-          <a:prstGeom prst="roundRect">
-            <a:avLst/>
-          </a:prstGeom>
-          <a:solidFill>
-            <a:srgbClr val="F3E8FF"/>
-          </a:solidFill>
-          <a:ln w="21590">
-            <a:solidFill>
-              <a:srgbClr val="7C3AED"/>
-            </a:solidFill>
-            <a:prstDash val="solid"/>
-          </a:ln>
-        </p:spPr>
-      </p:sp>
-      <p:sp>
-        <p:nvSpPr>
-          <p:cNvPr id="38" name="Text 36"/>
-          <p:cNvSpPr/>
-          <p:nvPr/>
-        </p:nvSpPr>
-        <p:spPr>
-          <a:xfrm>
-            <a:off x="1353312" y="4663440"/>
-            <a:ext cx="1179576" cy="274320"/>
-          </a:xfrm>
-          <a:prstGeom prst="rect">
-            <a:avLst/>
-          </a:prstGeom>
-          <a:noFill/>
-          <a:ln/>
-        </p:spPr>
-        <p:txBody>
-          <a:bodyPr wrap="square" lIns="635" tIns="635" rIns="635" bIns="635" rtlCol="0" anchor="ctr">
-            <a:normAutofit/>
-          </a:bodyPr>
-          <a:lstStyle/>
-          <a:p>
-            <a:pPr algn="ctr" indent="0" marL="0">
-              <a:buNone/>
-            </a:pPr>
-            <a:r>
-              <a:rPr lang="en-US" sz="1300" b="1" dirty="0">
-                <a:solidFill>
-                  <a:srgbClr val="7C3AED"/>
-                </a:solidFill>
-                <a:latin typeface="Microsoft JhengHei" pitchFamily="34" charset="0"/>
-                <a:ea typeface="Microsoft JhengHei" pitchFamily="34" charset="-122"/>
-                <a:cs typeface="Microsoft JhengHei" pitchFamily="34" charset="-120"/>
-              </a:rPr>
-              <a:t>重點字</a:t>
-            </a:r>
-            <a:endParaRPr lang="en-US" sz="1300" dirty="0"/>
-          </a:p>
-        </p:txBody>
-      </p:sp>
-      <p:sp>
-        <p:nvSpPr>
-          <p:cNvPr id="39" name="Text 37"/>
-          <p:cNvSpPr/>
-          <p:nvPr/>
-        </p:nvSpPr>
-        <p:spPr>
-          <a:xfrm>
-            <a:off x="2743200" y="4626864"/>
-            <a:ext cx="7452360" cy="420624"/>
-          </a:xfrm>
-          <a:prstGeom prst="rect">
-            <a:avLst/>
-          </a:prstGeom>
-          <a:noFill/>
-          <a:ln/>
-        </p:spPr>
-        <p:txBody>
-          <a:bodyPr wrap="square" lIns="635" tIns="635" rIns="635" bIns="635" rtlCol="0" anchor="ctr">
-            <a:normAutofit/>
-          </a:bodyPr>
-          <a:lstStyle/>
-          <a:p>
-            <a:pPr algn="l" indent="0" marL="0">
-              <a:buNone/>
-            </a:pPr>
-            <a:r>
-              <a:rPr lang="en-US" sz="1600" dirty="0">
-                <a:solidFill>
-                  <a:srgbClr val="163044"/>
-                </a:solidFill>
-                <a:latin typeface="Microsoft JhengHei" pitchFamily="34" charset="0"/>
-                <a:ea typeface="Microsoft JhengHei" pitchFamily="34" charset="-122"/>
-                <a:cs typeface="Microsoft JhengHei" pitchFamily="34" charset="-120"/>
-              </a:rPr>
-              <a:t>每人、有 20 人</a:t>
-            </a:r>
-            <a:endParaRPr lang="en-US" sz="1600" dirty="0"/>
-          </a:p>
-        </p:txBody>
-      </p:sp>
-      <p:sp>
-        <p:nvSpPr>
-          <p:cNvPr id="40" name="Shape 38"/>
-          <p:cNvSpPr/>
-          <p:nvPr/>
-        </p:nvSpPr>
-        <p:spPr>
-          <a:xfrm>
-            <a:off x="1325880" y="5047488"/>
-            <a:ext cx="1234440" cy="310896"/>
-          </a:xfrm>
-          <a:prstGeom prst="roundRect">
-            <a:avLst/>
-          </a:prstGeom>
-          <a:solidFill>
-            <a:srgbClr val="F3E8FF"/>
-          </a:solidFill>
-          <a:ln w="21590">
-            <a:solidFill>
-              <a:srgbClr val="7C3AED"/>
-            </a:solidFill>
-            <a:prstDash val="solid"/>
-          </a:ln>
-        </p:spPr>
-      </p:sp>
-      <p:sp>
-        <p:nvSpPr>
-          <p:cNvPr id="41" name="Text 39"/>
-          <p:cNvSpPr/>
-          <p:nvPr/>
-        </p:nvSpPr>
-        <p:spPr>
-          <a:xfrm>
-            <a:off x="1353312" y="5065776"/>
-            <a:ext cx="1179576" cy="274320"/>
-          </a:xfrm>
-          <a:prstGeom prst="rect">
-            <a:avLst/>
-          </a:prstGeom>
-          <a:noFill/>
-          <a:ln/>
-        </p:spPr>
-        <p:txBody>
-          <a:bodyPr wrap="square" lIns="635" tIns="635" rIns="635" bIns="635" rtlCol="0" anchor="ctr">
-            <a:normAutofit/>
-          </a:bodyPr>
-          <a:lstStyle/>
-          <a:p>
-            <a:pPr algn="ctr" indent="0" marL="0">
-              <a:buNone/>
-            </a:pPr>
-            <a:r>
-              <a:rPr lang="en-US" sz="1300" b="1" dirty="0">
-                <a:solidFill>
-                  <a:srgbClr val="7C3AED"/>
-                </a:solidFill>
-                <a:latin typeface="Microsoft JhengHei" pitchFamily="34" charset="0"/>
-                <a:ea typeface="Microsoft JhengHei" pitchFamily="34" charset="-122"/>
-                <a:cs typeface="Microsoft JhengHei" pitchFamily="34" charset="-120"/>
-              </a:rPr>
-              <a:t>判斷</a:t>
-            </a:r>
-            <a:endParaRPr lang="en-US" sz="1300" dirty="0"/>
-          </a:p>
-        </p:txBody>
-      </p:sp>
-      <p:sp>
-        <p:nvSpPr>
-          <p:cNvPr id="42" name="Text 40"/>
-          <p:cNvSpPr/>
-          <p:nvPr/>
-        </p:nvSpPr>
-        <p:spPr>
-          <a:xfrm>
-            <a:off x="2743200" y="5029200"/>
-            <a:ext cx="7452360" cy="420624"/>
-          </a:xfrm>
-          <a:prstGeom prst="rect">
-            <a:avLst/>
-          </a:prstGeom>
-          <a:noFill/>
-          <a:ln/>
-        </p:spPr>
-        <p:txBody>
-          <a:bodyPr wrap="square" lIns="635" tIns="635" rIns="635" bIns="635" rtlCol="0" anchor="ctr">
-            <a:normAutofit/>
-          </a:bodyPr>
-          <a:lstStyle/>
-          <a:p>
-            <a:pPr algn="l" indent="0" marL="0">
-              <a:buNone/>
-            </a:pPr>
-            <a:r>
-              <a:rPr lang="en-US" sz="1500" dirty="0">
-                <a:solidFill>
-                  <a:srgbClr val="163044"/>
-                </a:solidFill>
-                <a:latin typeface="Microsoft JhengHei" pitchFamily="34" charset="0"/>
-                <a:ea typeface="Microsoft JhengHei" pitchFamily="34" charset="-122"/>
-                <a:cs typeface="Microsoft JhengHei" pitchFamily="34" charset="-120"/>
-              </a:rPr>
-              <a:t>每人一樣多，用乘法。</a:t>
-            </a:r>
-            <a:endParaRPr lang="en-US" sz="1500" dirty="0"/>
-          </a:p>
-        </p:txBody>
-      </p:sp>
-      <p:sp>
-        <p:nvSpPr>
-          <p:cNvPr id="43" name="Shape 41"/>
-          <p:cNvSpPr/>
-          <p:nvPr/>
-        </p:nvSpPr>
-        <p:spPr>
-          <a:xfrm>
-            <a:off x="1325880" y="5440680"/>
-            <a:ext cx="1234440" cy="310896"/>
-          </a:xfrm>
-          <a:prstGeom prst="roundRect">
-            <a:avLst/>
-          </a:prstGeom>
-          <a:solidFill>
-            <a:srgbClr val="F3E8FF"/>
-          </a:solidFill>
-          <a:ln w="21590">
-            <a:solidFill>
-              <a:srgbClr val="7C3AED"/>
-            </a:solidFill>
-            <a:prstDash val="solid"/>
-          </a:ln>
-        </p:spPr>
-      </p:sp>
-      <p:sp>
-        <p:nvSpPr>
-          <p:cNvPr id="44" name="Text 42"/>
-          <p:cNvSpPr/>
-          <p:nvPr/>
-        </p:nvSpPr>
-        <p:spPr>
-          <a:xfrm>
-            <a:off x="1353312" y="5458968"/>
-            <a:ext cx="1179576" cy="274320"/>
-          </a:xfrm>
-          <a:prstGeom prst="rect">
-            <a:avLst/>
-          </a:prstGeom>
-          <a:noFill/>
-          <a:ln/>
-        </p:spPr>
-        <p:txBody>
-          <a:bodyPr wrap="square" lIns="635" tIns="635" rIns="635" bIns="635" rtlCol="0" anchor="ctr">
-            <a:normAutofit/>
-          </a:bodyPr>
-          <a:lstStyle/>
-          <a:p>
-            <a:pPr algn="ctr" indent="0" marL="0">
-              <a:buNone/>
-            </a:pPr>
-            <a:r>
-              <a:rPr lang="en-US" sz="1300" b="1" dirty="0">
-                <a:solidFill>
-                  <a:srgbClr val="7C3AED"/>
-                </a:solidFill>
-                <a:latin typeface="Microsoft JhengHei" pitchFamily="34" charset="0"/>
-                <a:ea typeface="Microsoft JhengHei" pitchFamily="34" charset="-122"/>
-                <a:cs typeface="Microsoft JhengHei" pitchFamily="34" charset="-120"/>
-              </a:rPr>
-              <a:t>算式</a:t>
-            </a:r>
-            <a:endParaRPr lang="en-US" sz="1300" dirty="0"/>
-          </a:p>
-        </p:txBody>
-      </p:sp>
-      <p:sp>
-        <p:nvSpPr>
-          <p:cNvPr id="45" name="Text 43"/>
-          <p:cNvSpPr/>
-          <p:nvPr/>
-        </p:nvSpPr>
-        <p:spPr>
-          <a:xfrm>
-            <a:off x="2743200" y="5422392"/>
-            <a:ext cx="7452360" cy="420624"/>
-          </a:xfrm>
-          <a:prstGeom prst="rect">
-            <a:avLst/>
-          </a:prstGeom>
-          <a:noFill/>
-          <a:ln/>
-        </p:spPr>
-        <p:txBody>
-          <a:bodyPr wrap="square" lIns="635" tIns="635" rIns="635" bIns="635" rtlCol="0" anchor="ctr">
-            <a:normAutofit/>
-          </a:bodyPr>
-          <a:lstStyle/>
-          <a:p>
-            <a:pPr algn="l" indent="0" marL="0">
-              <a:buNone/>
-            </a:pPr>
-            <a:r>
-              <a:rPr lang="en-US" sz="2000" b="1" dirty="0">
-                <a:solidFill>
-                  <a:srgbClr val="7C3AED"/>
-                </a:solidFill>
-                <a:latin typeface="Microsoft JhengHei" pitchFamily="34" charset="0"/>
-                <a:ea typeface="Microsoft JhengHei" pitchFamily="34" charset="-122"/>
-                <a:cs typeface="Microsoft JhengHei" pitchFamily="34" charset="-120"/>
-              </a:rPr>
-              <a:t>3 × 20 ＝ 60</a:t>
-            </a:r>
-            <a:endParaRPr lang="en-US" sz="2000" dirty="0"/>
-          </a:p>
-        </p:txBody>
-      </p:sp>
-      <p:sp>
-        <p:nvSpPr>
-          <p:cNvPr id="46" name="Shape 44"/>
-          <p:cNvSpPr/>
-          <p:nvPr/>
-        </p:nvSpPr>
-        <p:spPr>
-          <a:xfrm>
-            <a:off x="713232" y="6355080"/>
-            <a:ext cx="10332720" cy="1874520"/>
-          </a:xfrm>
-          <a:prstGeom prst="roundRect">
-            <a:avLst/>
-          </a:prstGeom>
-          <a:solidFill>
-            <a:srgbClr val="FFFFFF"/>
-          </a:solidFill>
-          <a:ln w="25400">
-            <a:solidFill>
-              <a:srgbClr val="DDD6FE"/>
-            </a:solidFill>
-            <a:prstDash val="solid"/>
-          </a:ln>
-        </p:spPr>
-      </p:sp>
-      <p:sp>
-        <p:nvSpPr>
-          <p:cNvPr id="47" name="Text 45"/>
-          <p:cNvSpPr/>
-          <p:nvPr/>
-        </p:nvSpPr>
-        <p:spPr>
-          <a:xfrm>
-            <a:off x="896112" y="6611112"/>
-            <a:ext cx="384048" cy="384048"/>
-          </a:xfrm>
-          <a:prstGeom prst="rect">
-            <a:avLst/>
-          </a:prstGeom>
-          <a:noFill/>
-          <a:ln/>
-        </p:spPr>
-        <p:txBody>
-          <a:bodyPr wrap="square" lIns="635" tIns="635" rIns="635" bIns="635" rtlCol="0" anchor="ctr">
-            <a:normAutofit/>
-          </a:bodyPr>
-          <a:lstStyle/>
-          <a:p>
-            <a:pPr algn="ctr" indent="0" marL="0">
-              <a:buNone/>
-            </a:pPr>
-            <a:r>
-              <a:rPr lang="en-US" sz="2600" b="1" dirty="0">
-                <a:solidFill>
-                  <a:srgbClr val="166534"/>
-                </a:solidFill>
-                <a:latin typeface="Microsoft JhengHei" pitchFamily="34" charset="0"/>
-                <a:ea typeface="Microsoft JhengHei" pitchFamily="34" charset="-122"/>
-                <a:cs typeface="Microsoft JhengHei" pitchFamily="34" charset="-120"/>
-              </a:rPr>
-              <a:t>✓</a:t>
-            </a:r>
-            <a:endParaRPr lang="en-US" sz="2600" dirty="0"/>
-          </a:p>
-        </p:txBody>
-      </p:sp>
-      <p:sp>
-        <p:nvSpPr>
-          <p:cNvPr id="48" name="Text 46"/>
-          <p:cNvSpPr/>
-          <p:nvPr/>
-        </p:nvSpPr>
-        <p:spPr>
-          <a:xfrm>
-            <a:off x="1325880" y="6565392"/>
-            <a:ext cx="1005840" cy="320040"/>
-          </a:xfrm>
-          <a:prstGeom prst="rect">
-            <a:avLst/>
-          </a:prstGeom>
-          <a:noFill/>
-          <a:ln/>
-        </p:spPr>
-        <p:txBody>
-          <a:bodyPr wrap="square" lIns="635" tIns="635" rIns="635" bIns="635" rtlCol="0" anchor="ctr">
-            <a:normAutofit/>
-          </a:bodyPr>
-          <a:lstStyle/>
-          <a:p>
-            <a:pPr algn="l" indent="0" marL="0">
-              <a:buNone/>
-            </a:pPr>
-            <a:r>
-              <a:rPr lang="en-US" sz="1900" b="1" dirty="0">
-                <a:solidFill>
-                  <a:srgbClr val="7C3AED"/>
-                </a:solidFill>
-                <a:latin typeface="Microsoft JhengHei" pitchFamily="34" charset="0"/>
-                <a:ea typeface="Microsoft JhengHei" pitchFamily="34" charset="-122"/>
-                <a:cs typeface="Microsoft JhengHei" pitchFamily="34" charset="-120"/>
-              </a:rPr>
-              <a:t>題目 C</a:t>
-            </a:r>
-            <a:endParaRPr lang="en-US" sz="1900" dirty="0"/>
-          </a:p>
-        </p:txBody>
-      </p:sp>
-      <p:sp>
-        <p:nvSpPr>
-          <p:cNvPr id="49" name="Shape 47"/>
-          <p:cNvSpPr/>
-          <p:nvPr/>
-        </p:nvSpPr>
-        <p:spPr>
-          <a:xfrm>
-            <a:off x="1325880" y="6976872"/>
-            <a:ext cx="1234440" cy="310896"/>
-          </a:xfrm>
-          <a:prstGeom prst="roundRect">
-            <a:avLst/>
-          </a:prstGeom>
-          <a:solidFill>
-            <a:srgbClr val="F3E8FF"/>
-          </a:solidFill>
-          <a:ln w="21590">
-            <a:solidFill>
-              <a:srgbClr val="7C3AED"/>
-            </a:solidFill>
-            <a:prstDash val="solid"/>
-          </a:ln>
-        </p:spPr>
-      </p:sp>
-      <p:sp>
-        <p:nvSpPr>
-          <p:cNvPr id="50" name="Text 48"/>
-          <p:cNvSpPr/>
-          <p:nvPr/>
-        </p:nvSpPr>
-        <p:spPr>
-          <a:xfrm>
-            <a:off x="1353312" y="6995160"/>
-            <a:ext cx="1179576" cy="274320"/>
-          </a:xfrm>
-          <a:prstGeom prst="rect">
-            <a:avLst/>
-          </a:prstGeom>
-          <a:noFill/>
-          <a:ln/>
-        </p:spPr>
-        <p:txBody>
-          <a:bodyPr wrap="square" lIns="635" tIns="635" rIns="635" bIns="635" rtlCol="0" anchor="ctr">
-            <a:normAutofit/>
-          </a:bodyPr>
-          <a:lstStyle/>
-          <a:p>
-            <a:pPr algn="ctr" indent="0" marL="0">
-              <a:buNone/>
-            </a:pPr>
-            <a:r>
-              <a:rPr lang="en-US" sz="1300" b="1" dirty="0">
-                <a:solidFill>
-                  <a:srgbClr val="7C3AED"/>
-                </a:solidFill>
-                <a:latin typeface="Microsoft JhengHei" pitchFamily="34" charset="0"/>
-                <a:ea typeface="Microsoft JhengHei" pitchFamily="34" charset="-122"/>
-                <a:cs typeface="Microsoft JhengHei" pitchFamily="34" charset="-120"/>
-              </a:rPr>
-              <a:t>重點字</a:t>
-            </a:r>
-            <a:endParaRPr lang="en-US" sz="1300" dirty="0"/>
-          </a:p>
-        </p:txBody>
-      </p:sp>
-      <p:sp>
-        <p:nvSpPr>
-          <p:cNvPr id="51" name="Text 49"/>
-          <p:cNvSpPr/>
-          <p:nvPr/>
-        </p:nvSpPr>
-        <p:spPr>
-          <a:xfrm>
-            <a:off x="2743200" y="6958584"/>
-            <a:ext cx="7452360" cy="420624"/>
-          </a:xfrm>
-          <a:prstGeom prst="rect">
-            <a:avLst/>
-          </a:prstGeom>
-          <a:noFill/>
-          <a:ln/>
-        </p:spPr>
-        <p:txBody>
-          <a:bodyPr wrap="square" lIns="635" tIns="635" rIns="635" bIns="635" rtlCol="0" anchor="ctr">
-            <a:normAutofit/>
-          </a:bodyPr>
-          <a:lstStyle/>
-          <a:p>
-            <a:pPr algn="l" indent="0" marL="0">
-              <a:buNone/>
-            </a:pPr>
-            <a:r>
-              <a:rPr lang="en-US" sz="1600" dirty="0">
-                <a:solidFill>
-                  <a:srgbClr val="163044"/>
-                </a:solidFill>
-                <a:latin typeface="Microsoft JhengHei" pitchFamily="34" charset="0"/>
-                <a:ea typeface="Microsoft JhengHei" pitchFamily="34" charset="-122"/>
-                <a:cs typeface="Microsoft JhengHei" pitchFamily="34" charset="-120"/>
-              </a:rPr>
-              <a:t>紅花和黃花合起來</a:t>
-            </a:r>
-            <a:endParaRPr lang="en-US" sz="1600" dirty="0"/>
-          </a:p>
-        </p:txBody>
-      </p:sp>
-      <p:sp>
-        <p:nvSpPr>
-          <p:cNvPr id="52" name="Shape 50"/>
-          <p:cNvSpPr/>
-          <p:nvPr/>
-        </p:nvSpPr>
-        <p:spPr>
-          <a:xfrm>
-            <a:off x="1325880" y="7379208"/>
-            <a:ext cx="1234440" cy="310896"/>
-          </a:xfrm>
-          <a:prstGeom prst="roundRect">
-            <a:avLst/>
-          </a:prstGeom>
-          <a:solidFill>
-            <a:srgbClr val="F3E8FF"/>
-          </a:solidFill>
-          <a:ln w="21590">
-            <a:solidFill>
-              <a:srgbClr val="7C3AED"/>
-            </a:solidFill>
-            <a:prstDash val="solid"/>
-          </a:ln>
-        </p:spPr>
-      </p:sp>
-      <p:sp>
-        <p:nvSpPr>
-          <p:cNvPr id="53" name="Text 51"/>
-          <p:cNvSpPr/>
-          <p:nvPr/>
-        </p:nvSpPr>
-        <p:spPr>
-          <a:xfrm>
-            <a:off x="1353312" y="7397496"/>
-            <a:ext cx="1179576" cy="274320"/>
-          </a:xfrm>
-          <a:prstGeom prst="rect">
-            <a:avLst/>
-          </a:prstGeom>
-          <a:noFill/>
-          <a:ln/>
-        </p:spPr>
-        <p:txBody>
-          <a:bodyPr wrap="square" lIns="635" tIns="635" rIns="635" bIns="635" rtlCol="0" anchor="ctr">
-            <a:normAutofit/>
-          </a:bodyPr>
-          <a:lstStyle/>
-          <a:p>
-            <a:pPr algn="ctr" indent="0" marL="0">
-              <a:buNone/>
-            </a:pPr>
-            <a:r>
-              <a:rPr lang="en-US" sz="1300" b="1" dirty="0">
-                <a:solidFill>
-                  <a:srgbClr val="7C3AED"/>
-                </a:solidFill>
-                <a:latin typeface="Microsoft JhengHei" pitchFamily="34" charset="0"/>
-                <a:ea typeface="Microsoft JhengHei" pitchFamily="34" charset="-122"/>
-                <a:cs typeface="Microsoft JhengHei" pitchFamily="34" charset="-120"/>
-              </a:rPr>
-              <a:t>判斷</a:t>
-            </a:r>
-            <a:endParaRPr lang="en-US" sz="1300" dirty="0"/>
-          </a:p>
-        </p:txBody>
-      </p:sp>
-      <p:sp>
-        <p:nvSpPr>
-          <p:cNvPr id="54" name="Text 52"/>
-          <p:cNvSpPr/>
-          <p:nvPr/>
-        </p:nvSpPr>
-        <p:spPr>
-          <a:xfrm>
-            <a:off x="2743200" y="7360920"/>
-            <a:ext cx="7452360" cy="420624"/>
-          </a:xfrm>
-          <a:prstGeom prst="rect">
-            <a:avLst/>
-          </a:prstGeom>
-          <a:noFill/>
-          <a:ln/>
-        </p:spPr>
-        <p:txBody>
-          <a:bodyPr wrap="square" lIns="635" tIns="635" rIns="635" bIns="635" rtlCol="0" anchor="ctr">
-            <a:normAutofit/>
-          </a:bodyPr>
-          <a:lstStyle/>
-          <a:p>
-            <a:pPr algn="l" indent="0" marL="0">
-              <a:buNone/>
-            </a:pPr>
-            <a:r>
-              <a:rPr lang="en-US" sz="1500" dirty="0">
-                <a:solidFill>
-                  <a:srgbClr val="163044"/>
-                </a:solidFill>
-                <a:latin typeface="Microsoft JhengHei" pitchFamily="34" charset="0"/>
-                <a:ea typeface="Microsoft JhengHei" pitchFamily="34" charset="-122"/>
-                <a:cs typeface="Microsoft JhengHei" pitchFamily="34" charset="-120"/>
-              </a:rPr>
-              <a:t>兩種花合共，用加法。</a:t>
-            </a:r>
-            <a:endParaRPr lang="en-US" sz="1500" dirty="0"/>
-          </a:p>
-        </p:txBody>
-      </p:sp>
-      <p:sp>
-        <p:nvSpPr>
-          <p:cNvPr id="55" name="Shape 53"/>
-          <p:cNvSpPr/>
-          <p:nvPr/>
-        </p:nvSpPr>
-        <p:spPr>
-          <a:xfrm>
-            <a:off x="1325880" y="7772400"/>
-            <a:ext cx="1234440" cy="310896"/>
-          </a:xfrm>
-          <a:prstGeom prst="roundRect">
-            <a:avLst/>
-          </a:prstGeom>
-          <a:solidFill>
-            <a:srgbClr val="F3E8FF"/>
-          </a:solidFill>
-          <a:ln w="21590">
-            <a:solidFill>
-              <a:srgbClr val="7C3AED"/>
-            </a:solidFill>
-            <a:prstDash val="solid"/>
-          </a:ln>
-        </p:spPr>
-      </p:sp>
-      <p:sp>
-        <p:nvSpPr>
-          <p:cNvPr id="56" name="Text 54"/>
-          <p:cNvSpPr/>
-          <p:nvPr/>
-        </p:nvSpPr>
-        <p:spPr>
-          <a:xfrm>
-            <a:off x="1353312" y="7790688"/>
-            <a:ext cx="1179576" cy="274320"/>
-          </a:xfrm>
-          <a:prstGeom prst="rect">
-            <a:avLst/>
-          </a:prstGeom>
-          <a:noFill/>
-          <a:ln/>
-        </p:spPr>
-        <p:txBody>
-          <a:bodyPr wrap="square" lIns="635" tIns="635" rIns="635" bIns="635" rtlCol="0" anchor="ctr">
-            <a:normAutofit/>
-          </a:bodyPr>
-          <a:lstStyle/>
-          <a:p>
-            <a:pPr algn="ctr" indent="0" marL="0">
-              <a:buNone/>
-            </a:pPr>
-            <a:r>
-              <a:rPr lang="en-US" sz="1300" b="1" dirty="0">
-                <a:solidFill>
-                  <a:srgbClr val="7C3AED"/>
-                </a:solidFill>
-                <a:latin typeface="Microsoft JhengHei" pitchFamily="34" charset="0"/>
-                <a:ea typeface="Microsoft JhengHei" pitchFamily="34" charset="-122"/>
-                <a:cs typeface="Microsoft JhengHei" pitchFamily="34" charset="-120"/>
-              </a:rPr>
-              <a:t>算式</a:t>
-            </a:r>
-            <a:endParaRPr lang="en-US" sz="1300" dirty="0"/>
-          </a:p>
-        </p:txBody>
-      </p:sp>
-      <p:sp>
-        <p:nvSpPr>
-          <p:cNvPr id="57" name="Text 55"/>
-          <p:cNvSpPr/>
-          <p:nvPr/>
-        </p:nvSpPr>
-        <p:spPr>
-          <a:xfrm>
-            <a:off x="2743200" y="7754112"/>
-            <a:ext cx="7452360" cy="420624"/>
-          </a:xfrm>
-          <a:prstGeom prst="rect">
-            <a:avLst/>
-          </a:prstGeom>
-          <a:noFill/>
-          <a:ln/>
-        </p:spPr>
-        <p:txBody>
-          <a:bodyPr wrap="square" lIns="635" tIns="635" rIns="635" bIns="635" rtlCol="0" anchor="ctr">
-            <a:normAutofit/>
-          </a:bodyPr>
-          <a:lstStyle/>
-          <a:p>
-            <a:pPr algn="l" indent="0" marL="0">
-              <a:buNone/>
-            </a:pPr>
-            <a:r>
-              <a:rPr lang="en-US" sz="2000" b="1" dirty="0">
-                <a:solidFill>
-                  <a:srgbClr val="7C3AED"/>
-                </a:solidFill>
-                <a:latin typeface="Microsoft JhengHei" pitchFamily="34" charset="0"/>
-                <a:ea typeface="Microsoft JhengHei" pitchFamily="34" charset="-122"/>
-                <a:cs typeface="Microsoft JhengHei" pitchFamily="34" charset="-120"/>
-              </a:rPr>
               <a:t>18 ＋ 15 ＝ 33</a:t>
             </a:r>
-            <a:endParaRPr lang="en-US" sz="2000" dirty="0"/>
+            <a:endParaRPr lang="en-US" sz="1550" dirty="0"/>
           </a:p>
         </p:txBody>
       </p:sp>
@@ -46200,7 +46200,24 @@
                 <a:ea typeface="Microsoft JhengHei" pitchFamily="34" charset="-122"/>
                 <a:cs typeface="Microsoft JhengHei" pitchFamily="34" charset="-120"/>
               </a:rPr>
-              <a:t>相差、比……多、比……少</a:t>
+              <a:t>相差</a:t>
+            </a:r>
+            <a:endParaRPr lang="en-US" sz="2100" dirty="0"/>
+          </a:p>
+          <a:p>
+            <a:pPr algn="ctr" indent="0" marL="0">
+              <a:buNone/>
+            </a:pPr>
+            <a:r>
+              <a:rPr lang="en-US" sz="2100" b="1" dirty="0">
+                <a:solidFill>
+                  <a:srgbClr val="163044"/>
+                </a:solidFill>
+                <a:latin typeface="Microsoft JhengHei" pitchFamily="34" charset="0"/>
+                <a:ea typeface="Microsoft JhengHei" pitchFamily="34" charset="-122"/>
+                <a:cs typeface="Microsoft JhengHei" pitchFamily="34" charset="-120"/>
+              </a:rPr>
+              <a:t>比……多、比……少</a:t>
             </a:r>
             <a:endParaRPr lang="en-US" sz="2100" dirty="0"/>
           </a:p>
@@ -54581,7 +54598,7 @@
         <p:spPr>
           <a:xfrm>
             <a:off x="1325880" y="1901952"/>
-            <a:ext cx="1005840" cy="320040"/>
+            <a:ext cx="1005840" cy="292608"/>
           </a:xfrm>
           <a:prstGeom prst="rect">
             <a:avLst/>
@@ -54688,7 +54705,7 @@
         <p:spPr>
           <a:xfrm>
             <a:off x="2743200" y="2295144"/>
-            <a:ext cx="7452360" cy="420624"/>
+            <a:ext cx="7452360" cy="310896"/>
           </a:xfrm>
           <a:prstGeom prst="rect">
             <a:avLst/>
@@ -54795,7 +54812,7 @@
         <p:spPr>
           <a:xfrm>
             <a:off x="2743200" y="2697480"/>
-            <a:ext cx="7452360" cy="420624"/>
+            <a:ext cx="7452360" cy="292608"/>
           </a:xfrm>
           <a:prstGeom prst="rect">
             <a:avLst/>
@@ -54902,7 +54919,7 @@
         <p:spPr>
           <a:xfrm>
             <a:off x="2743200" y="3090672"/>
-            <a:ext cx="7452360" cy="420624"/>
+            <a:ext cx="7452360" cy="292608"/>
           </a:xfrm>
           <a:prstGeom prst="rect">
             <a:avLst/>
@@ -55009,7 +55026,7 @@
         <p:spPr>
           <a:xfrm>
             <a:off x="1325880" y="4233672"/>
-            <a:ext cx="1005840" cy="320040"/>
+            <a:ext cx="1005840" cy="292608"/>
           </a:xfrm>
           <a:prstGeom prst="rect">
             <a:avLst/>
@@ -55116,7 +55133,7 @@
         <p:spPr>
           <a:xfrm>
             <a:off x="2743200" y="4626864"/>
-            <a:ext cx="7452360" cy="420624"/>
+            <a:ext cx="7452360" cy="310896"/>
           </a:xfrm>
           <a:prstGeom prst="rect">
             <a:avLst/>
@@ -55223,7 +55240,7 @@
         <p:spPr>
           <a:xfrm>
             <a:off x="2743200" y="5029200"/>
-            <a:ext cx="7452360" cy="420624"/>
+            <a:ext cx="7452360" cy="292608"/>
           </a:xfrm>
           <a:prstGeom prst="rect">
             <a:avLst/>
@@ -55330,7 +55347,7 @@
         <p:spPr>
           <a:xfrm>
             <a:off x="2743200" y="5422392"/>
-            <a:ext cx="7452360" cy="420624"/>
+            <a:ext cx="7452360" cy="292608"/>
           </a:xfrm>
           <a:prstGeom prst="rect">
             <a:avLst/>
@@ -60944,7 +60961,7 @@
         <p:spPr>
           <a:xfrm>
             <a:off x="1325880" y="1901952"/>
-            <a:ext cx="1005840" cy="320040"/>
+            <a:ext cx="1005840" cy="292608"/>
           </a:xfrm>
           <a:prstGeom prst="rect">
             <a:avLst/>
@@ -61051,7 +61068,7 @@
         <p:spPr>
           <a:xfrm>
             <a:off x="2743200" y="2295144"/>
-            <a:ext cx="7452360" cy="420624"/>
+            <a:ext cx="7452360" cy="310896"/>
           </a:xfrm>
           <a:prstGeom prst="rect">
             <a:avLst/>
@@ -61158,7 +61175,7 @@
         <p:spPr>
           <a:xfrm>
             <a:off x="2743200" y="2697480"/>
-            <a:ext cx="7452360" cy="420624"/>
+            <a:ext cx="7452360" cy="292608"/>
           </a:xfrm>
           <a:prstGeom prst="rect">
             <a:avLst/>
@@ -61265,7 +61282,7 @@
         <p:spPr>
           <a:xfrm>
             <a:off x="2743200" y="3090672"/>
-            <a:ext cx="7452360" cy="420624"/>
+            <a:ext cx="7452360" cy="292608"/>
           </a:xfrm>
           <a:prstGeom prst="rect">
             <a:avLst/>
@@ -61372,7 +61389,7 @@
         <p:spPr>
           <a:xfrm>
             <a:off x="1325880" y="4233672"/>
-            <a:ext cx="1005840" cy="320040"/>
+            <a:ext cx="1005840" cy="292608"/>
           </a:xfrm>
           <a:prstGeom prst="rect">
             <a:avLst/>
@@ -61479,7 +61496,7 @@
         <p:spPr>
           <a:xfrm>
             <a:off x="2743200" y="4626864"/>
-            <a:ext cx="7452360" cy="420624"/>
+            <a:ext cx="7452360" cy="310896"/>
           </a:xfrm>
           <a:prstGeom prst="rect">
             <a:avLst/>
@@ -61586,7 +61603,7 @@
         <p:spPr>
           <a:xfrm>
             <a:off x="2743200" y="5029200"/>
-            <a:ext cx="7452360" cy="420624"/>
+            <a:ext cx="7452360" cy="292608"/>
           </a:xfrm>
           <a:prstGeom prst="rect">
             <a:avLst/>
@@ -61693,7 +61710,7 @@
         <p:spPr>
           <a:xfrm>
             <a:off x="2743200" y="5422392"/>
-            <a:ext cx="7452360" cy="420624"/>
+            <a:ext cx="7452360" cy="292608"/>
           </a:xfrm>
           <a:prstGeom prst="rect">
             <a:avLst/>

</xml_diff>